<commit_message>
fixed reference to M04 (now M08)
</commit_message>
<xml_diff>
--- a/Slides/Module 16 Using AI Agents.pptx
+++ b/Slides/Module 16 Using AI Agents.pptx
@@ -310,7 +310,7 @@
           <a:p>
             <a:fld id="{7C7E5181-6CF5-45F7-A87A-E0E0B1FD7549}" type="datetimeFigureOut">
               <a:rPr lang="en-US" smtClean="0"/>
-              <a:t>3/18/2026</a:t>
+              <a:t>3/23/2026</a:t>
             </a:fld>
             <a:endParaRPr lang="en-US"/>
           </a:p>
@@ -2233,7 +2233,7 @@
           <a:p>
             <a:fld id="{5D2A64DE-480B-420F-9649-4F8E696E08E0}" type="datetime1">
               <a:rPr lang="en-US" smtClean="0"/>
-              <a:t>3/18/2026</a:t>
+              <a:t>3/23/2026</a:t>
             </a:fld>
             <a:endParaRPr lang="en-US"/>
           </a:p>
@@ -2557,7 +2557,7 @@
           <a:p>
             <a:fld id="{EA476A42-A091-4468-A075-64A31BE59948}" type="datetime1">
               <a:rPr lang="en-US" smtClean="0"/>
-              <a:t>3/18/2026</a:t>
+              <a:t>3/23/2026</a:t>
             </a:fld>
             <a:endParaRPr lang="en-US"/>
           </a:p>
@@ -2755,7 +2755,7 @@
           <a:p>
             <a:fld id="{0D3616D0-8311-4107-9726-6B805E7D05BA}" type="datetime1">
               <a:rPr lang="en-US" smtClean="0"/>
-              <a:t>3/18/2026</a:t>
+              <a:t>3/23/2026</a:t>
             </a:fld>
             <a:endParaRPr lang="en-US"/>
           </a:p>
@@ -2963,7 +2963,7 @@
           <a:p>
             <a:fld id="{3BC2557A-5C88-417A-A763-5AC779462A5F}" type="datetime1">
               <a:rPr lang="en-US" smtClean="0"/>
-              <a:t>3/18/2026</a:t>
+              <a:t>3/23/2026</a:t>
             </a:fld>
             <a:endParaRPr lang="en-US"/>
           </a:p>
@@ -3487,7 +3487,7 @@
           <a:p>
             <a:fld id="{07C7BFD4-467E-4EDE-93EA-052F5B39A4E5}" type="datetime1">
               <a:rPr lang="en-US" smtClean="0"/>
-              <a:t>3/18/2026</a:t>
+              <a:t>3/23/2026</a:t>
             </a:fld>
             <a:endParaRPr lang="en-US"/>
           </a:p>
@@ -3737,7 +3737,7 @@
           <a:p>
             <a:fld id="{07C7BFD4-467E-4EDE-93EA-052F5B39A4E5}" type="datetime1">
               <a:rPr lang="en-US" smtClean="0"/>
-              <a:t>3/18/2026</a:t>
+              <a:t>3/23/2026</a:t>
             </a:fld>
             <a:endParaRPr lang="en-US"/>
           </a:p>
@@ -3919,7 +3919,7 @@
           <a:p>
             <a:fld id="{109E55A0-C911-4F03-82FC-7E5926047D46}" type="datetime1">
               <a:rPr lang="en-US" smtClean="0"/>
-              <a:t>3/18/2026</a:t>
+              <a:t>3/23/2026</a:t>
             </a:fld>
             <a:endParaRPr lang="en-US"/>
           </a:p>
@@ -4232,7 +4232,7 @@
           <a:p>
             <a:fld id="{A533CBE2-D5BE-47AC-ADC2-9CDFC1D0CF90}" type="datetime1">
               <a:rPr lang="en-US" smtClean="0"/>
-              <a:t>3/18/2026</a:t>
+              <a:t>3/23/2026</a:t>
             </a:fld>
             <a:endParaRPr lang="en-US"/>
           </a:p>
@@ -4533,7 +4533,7 @@
           <a:p>
             <a:fld id="{39B7EDB1-CE74-4951-85A2-0B01C2128E28}" type="datetime1">
               <a:rPr lang="en-US" smtClean="0"/>
-              <a:t>3/18/2026</a:t>
+              <a:t>3/23/2026</a:t>
             </a:fld>
             <a:endParaRPr lang="en-US"/>
           </a:p>
@@ -4981,7 +4981,7 @@
           <a:p>
             <a:fld id="{2BC7EB92-A5C2-4807-A9DC-9EDE6CBFB241}" type="datetime1">
               <a:rPr lang="en-US" smtClean="0"/>
-              <a:t>3/18/2026</a:t>
+              <a:t>3/23/2026</a:t>
             </a:fld>
             <a:endParaRPr lang="en-US"/>
           </a:p>
@@ -5094,7 +5094,7 @@
           <a:p>
             <a:fld id="{2B7B7EE0-7771-4CD5-9B2B-3550753A54A1}" type="datetime1">
               <a:rPr lang="en-US" smtClean="0"/>
-              <a:t>3/18/2026</a:t>
+              <a:t>3/23/2026</a:t>
             </a:fld>
             <a:endParaRPr lang="en-US"/>
           </a:p>
@@ -5405,7 +5405,7 @@
           <a:p>
             <a:fld id="{F8B318B3-0E87-4416-A9B8-D891968C2727}" type="datetime1">
               <a:rPr lang="en-US" smtClean="0"/>
-              <a:t>3/18/2026</a:t>
+              <a:t>3/23/2026</a:t>
             </a:fld>
             <a:endParaRPr lang="en-US"/>
           </a:p>
@@ -5646,7 +5646,7 @@
           <a:p>
             <a:fld id="{54D997E8-DDEE-43F1-8D9B-F8A1E11DE488}" type="datetime1">
               <a:rPr lang="en-US" smtClean="0"/>
-              <a:t>3/18/2026</a:t>
+              <a:t>3/23/2026</a:t>
             </a:fld>
             <a:endParaRPr lang="en-US"/>
           </a:p>
@@ -13920,71 +13920,7 @@
                 <a:effectLst/>
                 <a:latin typeface="Consolas" panose="020B0609020204030204" pitchFamily="49" charset="0"/>
               </a:rPr>
-              <a:t>Remember this slide from Module 04 Code Level Design?</a:t>
-            </a:r>
-          </a:p>
-        </p:txBody>
-      </p:sp>
-      <p:sp>
-        <p:nvSpPr>
-          <p:cNvPr id="5" name="TextBox 4">
-            <a:extLst>
-              <a:ext uri="{FF2B5EF4-FFF2-40B4-BE49-F238E27FC236}">
-                <a16:creationId xmlns:a16="http://schemas.microsoft.com/office/drawing/2014/main" id="{A613E17C-933C-658D-4559-211A9AE8B6FE}"/>
-              </a:ext>
-            </a:extLst>
-          </p:cNvPr>
-          <p:cNvSpPr txBox="1"/>
-          <p:nvPr/>
-        </p:nvSpPr>
-        <p:spPr>
-          <a:xfrm>
-            <a:off x="8439912" y="3675829"/>
-            <a:ext cx="2825496" cy="2066544"/>
-          </a:xfrm>
-          <a:prstGeom prst="rect">
-            <a:avLst/>
-          </a:prstGeom>
-          <a:solidFill>
-            <a:srgbClr val="FFFF00"/>
-          </a:solidFill>
-          <a:ln>
-            <a:noFill/>
-          </a:ln>
-        </p:spPr>
-        <p:style>
-          <a:lnRef idx="2">
-            <a:schemeClr val="accent1">
-              <a:shade val="50000"/>
-            </a:schemeClr>
-          </a:lnRef>
-          <a:fillRef idx="1">
-            <a:schemeClr val="accent1"/>
-          </a:fillRef>
-          <a:effectRef idx="0">
-            <a:schemeClr val="accent1"/>
-          </a:effectRef>
-          <a:fontRef idx="minor">
-            <a:schemeClr val="lt1"/>
-          </a:fontRef>
-        </p:style>
-        <p:txBody>
-          <a:bodyPr rot="0" spcFirstLastPara="0" vertOverflow="overflow" horzOverflow="overflow" vert="horz" wrap="square" lIns="91440" tIns="45720" rIns="91440" bIns="45720" numCol="1" spcCol="0" rtlCol="0" fromWordArt="0" anchor="ctr" anchorCtr="0" forceAA="0" compatLnSpc="1">
-            <a:prstTxWarp prst="textNoShape">
-              <a:avLst/>
-            </a:prstTxWarp>
-            <a:noAutofit/>
-          </a:bodyPr>
-          <a:lstStyle/>
-          <a:p>
-            <a:pPr algn="l"/>
-            <a:r>
-              <a:rPr lang="en-US" dirty="0">
-                <a:solidFill>
-                  <a:schemeClr val="tx1"/>
-                </a:solidFill>
-              </a:rPr>
-              <a:t>Did we actually use this slide in Spring 2026???</a:t>
+              <a:t>Remember this slide from Module 08 Code Level Design?</a:t>
             </a:r>
           </a:p>
         </p:txBody>

</xml_diff>

<commit_message>
Add slide to AI agents
</commit_message>
<xml_diff>
--- a/Slides/Module 16 Using AI Agents.pptx
+++ b/Slides/Module 16 Using AI Agents.pptx
@@ -5,7 +5,7 @@
     <p:sldMasterId id="2147483648" r:id="rId1"/>
   </p:sldMasterIdLst>
   <p:notesMasterIdLst>
-    <p:notesMasterId r:id="rId51"/>
+    <p:notesMasterId r:id="rId52"/>
   </p:notesMasterIdLst>
   <p:sldIdLst>
     <p:sldId id="485" r:id="rId2"/>
@@ -51,29 +51,30 @@
     <p:sldId id="750" r:id="rId42"/>
     <p:sldId id="611" r:id="rId43"/>
     <p:sldId id="734" r:id="rId44"/>
-    <p:sldId id="759" r:id="rId45"/>
-    <p:sldId id="621" r:id="rId46"/>
-    <p:sldId id="622" r:id="rId47"/>
-    <p:sldId id="744" r:id="rId48"/>
-    <p:sldId id="760" r:id="rId49"/>
-    <p:sldId id="745" r:id="rId50"/>
+    <p:sldId id="761" r:id="rId45"/>
+    <p:sldId id="759" r:id="rId46"/>
+    <p:sldId id="621" r:id="rId47"/>
+    <p:sldId id="622" r:id="rId48"/>
+    <p:sldId id="744" r:id="rId49"/>
+    <p:sldId id="760" r:id="rId50"/>
+    <p:sldId id="745" r:id="rId51"/>
   </p:sldIdLst>
   <p:sldSz cx="12192000" cy="6858000"/>
   <p:notesSz cx="6858000" cy="9144000"/>
   <p:embeddedFontLst>
     <p:embeddedFont>
       <p:font typeface="Consolas" panose="020B0609020204030204" pitchFamily="49" charset="0"/>
-      <p:regular r:id="rId52"/>
-      <p:bold r:id="rId53"/>
-      <p:italic r:id="rId54"/>
-      <p:boldItalic r:id="rId55"/>
+      <p:regular r:id="rId53"/>
+      <p:bold r:id="rId54"/>
+      <p:italic r:id="rId55"/>
+      <p:boldItalic r:id="rId56"/>
     </p:embeddedFont>
     <p:embeddedFont>
       <p:font typeface="Verdana" panose="020B0604030504040204" pitchFamily="34" charset="0"/>
-      <p:regular r:id="rId56"/>
-      <p:bold r:id="rId57"/>
-      <p:italic r:id="rId58"/>
-      <p:boldItalic r:id="rId59"/>
+      <p:regular r:id="rId57"/>
+      <p:bold r:id="rId58"/>
+      <p:italic r:id="rId59"/>
+      <p:boldItalic r:id="rId60"/>
     </p:embeddedFont>
   </p:embeddedFontLst>
   <p:defaultTextStyle>
@@ -219,6 +220,7 @@
             <p14:sldId id="750"/>
             <p14:sldId id="611"/>
             <p14:sldId id="734"/>
+            <p14:sldId id="761"/>
             <p14:sldId id="759"/>
             <p14:sldId id="621"/>
             <p14:sldId id="622"/>
@@ -326,7 +328,7 @@
           <a:p>
             <a:fld id="{7C7E5181-6CF5-45F7-A87A-E0E0B1FD7549}" type="datetimeFigureOut">
               <a:rPr lang="en-US" smtClean="0"/>
-              <a:t>3/29/2026</a:t>
+              <a:t>3/31/26</a:t>
             </a:fld>
             <a:endParaRPr lang="en-US"/>
           </a:p>
@@ -1815,6 +1817,57 @@
           <a:bodyPr/>
           <a:lstStyle/>
           <a:p>
+            <a:r>
+              <a:rPr lang="en-US" dirty="0"/>
+              <a:t>Just like you have different team members with different skills, recently a lot of attention has been given to making teams of AI agents that are given specific role-playing instructions: “you’re in charge of keeping everyone on task,” “you’re in charge of reviewing PRs for frontend engineering,” “you are here to do one specific task described in this pull request and then go away forever” (Mr. </a:t>
+            </a:r>
+            <a:r>
+              <a:rPr lang="en-US" dirty="0" err="1"/>
+              <a:t>Meeseeks</a:t>
+            </a:r>
+            <a:r>
+              <a:rPr lang="en-US" dirty="0"/>
+              <a:t> is the appropriate Rick and Morty reference if you’re so inclined)</a:t>
+            </a:r>
+          </a:p>
+          <a:p>
+            <a:endParaRPr lang="en-US" dirty="0"/>
+          </a:p>
+          <a:p>
+            <a:r>
+              <a:rPr lang="en-US" dirty="0"/>
+              <a:t>This is a screenshot that Prof. Simmons saw on Monday. It’s a log of a python script — written primarily with Claude — showing the workflow by which dozens of Claude agents are collaborating by filing GitHub issues and closing them with PRs, which other agents are closing.</a:t>
+            </a:r>
+          </a:p>
+          <a:p>
+            <a:endParaRPr lang="en-US" dirty="0"/>
+          </a:p>
+          <a:p>
+            <a:r>
+              <a:rPr lang="en-US" dirty="0"/>
+              <a:t>Nobody at present thinks this kind of workflow produces good software engineering — software maintainable </a:t>
+            </a:r>
+            <a:r>
+              <a:rPr lang="en-US" i="1" dirty="0"/>
+              <a:t>over time</a:t>
+            </a:r>
+            <a:r>
+              <a:rPr lang="en-US" i="0" dirty="0"/>
+              <a:t> — but it is demonstrably better at doing certain goal-oriented complex tasks (like searching for bugs in a compiler).</a:t>
+            </a:r>
+          </a:p>
+          <a:p>
+            <a:endParaRPr lang="en-US" i="0" dirty="0"/>
+          </a:p>
+          <a:p>
+            <a:r>
+              <a:rPr lang="en-US" i="0"/>
+              <a:t>(It </a:t>
+            </a:r>
+            <a:r>
+              <a:rPr lang="en-US" i="0" dirty="0"/>
+              <a:t>can be emotionally exhausting to argue with an AI agent, but AI agents don’t experience emotional exhaustion and can yell at each other)</a:t>
+            </a:r>
             <a:endParaRPr lang="en-US" dirty="0"/>
           </a:p>
         </p:txBody>
@@ -1836,7 +1889,91 @@
           <a:p>
             <a:fld id="{07937F07-1250-4CCE-B198-1B2887014F41}" type="slidenum">
               <a:rPr lang="en-US" smtClean="0"/>
-              <a:t>47</a:t>
+              <a:t>44</a:t>
+            </a:fld>
+            <a:endParaRPr lang="en-US"/>
+          </a:p>
+        </p:txBody>
+      </p:sp>
+    </p:spTree>
+    <p:extLst>
+      <p:ext uri="{BB962C8B-B14F-4D97-AF65-F5344CB8AC3E}">
+        <p14:creationId xmlns:p14="http://schemas.microsoft.com/office/powerpoint/2010/main" val="3470003817"/>
+      </p:ext>
+    </p:extLst>
+  </p:cSld>
+  <p:clrMapOvr>
+    <a:masterClrMapping/>
+  </p:clrMapOvr>
+</p:notes>
+</file>
+
+<file path=ppt/notesSlides/notesSlide21.xml><?xml version="1.0" encoding="utf-8"?>
+<p:notes xmlns:a="http://schemas.openxmlformats.org/drawingml/2006/main" xmlns:r="http://schemas.openxmlformats.org/officeDocument/2006/relationships" xmlns:p="http://schemas.openxmlformats.org/presentationml/2006/main">
+  <p:cSld>
+    <p:spTree>
+      <p:nvGrpSpPr>
+        <p:cNvPr id="1" name=""/>
+        <p:cNvGrpSpPr/>
+        <p:nvPr/>
+      </p:nvGrpSpPr>
+      <p:grpSpPr>
+        <a:xfrm>
+          <a:off x="0" y="0"/>
+          <a:ext cx="0" cy="0"/>
+          <a:chOff x="0" y="0"/>
+          <a:chExt cx="0" cy="0"/>
+        </a:xfrm>
+      </p:grpSpPr>
+      <p:sp>
+        <p:nvSpPr>
+          <p:cNvPr id="2" name="Slide Image Placeholder 1"/>
+          <p:cNvSpPr>
+            <a:spLocks noGrp="1" noRot="1" noChangeAspect="1"/>
+          </p:cNvSpPr>
+          <p:nvPr>
+            <p:ph type="sldImg"/>
+          </p:nvPr>
+        </p:nvSpPr>
+        <p:spPr/>
+      </p:sp>
+      <p:sp>
+        <p:nvSpPr>
+          <p:cNvPr id="3" name="Notes Placeholder 2"/>
+          <p:cNvSpPr>
+            <a:spLocks noGrp="1"/>
+          </p:cNvSpPr>
+          <p:nvPr>
+            <p:ph type="body" idx="1"/>
+          </p:nvPr>
+        </p:nvSpPr>
+        <p:spPr/>
+        <p:txBody>
+          <a:bodyPr/>
+          <a:lstStyle/>
+          <a:p>
+            <a:endParaRPr lang="en-US" dirty="0"/>
+          </a:p>
+        </p:txBody>
+      </p:sp>
+      <p:sp>
+        <p:nvSpPr>
+          <p:cNvPr id="4" name="Slide Number Placeholder 3"/>
+          <p:cNvSpPr>
+            <a:spLocks noGrp="1"/>
+          </p:cNvSpPr>
+          <p:nvPr>
+            <p:ph type="sldNum" sz="quarter" idx="5"/>
+          </p:nvPr>
+        </p:nvSpPr>
+        <p:spPr/>
+        <p:txBody>
+          <a:bodyPr/>
+          <a:lstStyle/>
+          <a:p>
+            <a:fld id="{07937F07-1250-4CCE-B198-1B2887014F41}" type="slidenum">
+              <a:rPr lang="en-US" smtClean="0"/>
+              <a:t>48</a:t>
             </a:fld>
             <a:endParaRPr lang="en-US"/>
           </a:p>
@@ -1855,7 +1992,7 @@
 </p:notes>
 </file>
 
-<file path=ppt/notesSlides/notesSlide21.xml><?xml version="1.0" encoding="utf-8"?>
+<file path=ppt/notesSlides/notesSlide22.xml><?xml version="1.0" encoding="utf-8"?>
 <p:notes xmlns:a="http://schemas.openxmlformats.org/drawingml/2006/main" xmlns:r="http://schemas.openxmlformats.org/officeDocument/2006/relationships" xmlns:p="http://schemas.openxmlformats.org/presentationml/2006/main">
   <p:cSld>
     <p:spTree>
@@ -1947,7 +2084,7 @@
           <a:p>
             <a:fld id="{07937F07-1250-4CCE-B198-1B2887014F41}" type="slidenum">
               <a:rPr lang="en-US" smtClean="0"/>
-              <a:t>48</a:t>
+              <a:t>49</a:t>
             </a:fld>
             <a:endParaRPr lang="en-US"/>
           </a:p>
@@ -1966,7 +2103,7 @@
 </p:notes>
 </file>
 
-<file path=ppt/notesSlides/notesSlide22.xml><?xml version="1.0" encoding="utf-8"?>
+<file path=ppt/notesSlides/notesSlide23.xml><?xml version="1.0" encoding="utf-8"?>
 <p:notes xmlns:a="http://schemas.openxmlformats.org/drawingml/2006/main" xmlns:r="http://schemas.openxmlformats.org/officeDocument/2006/relationships" xmlns:p="http://schemas.openxmlformats.org/presentationml/2006/main">
   <p:cSld>
     <p:spTree>
@@ -2070,7 +2207,7 @@
           <a:p>
             <a:fld id="{07937F07-1250-4CCE-B198-1B2887014F41}" type="slidenum">
               <a:rPr lang="en-US" smtClean="0"/>
-              <a:t>49</a:t>
+              <a:t>50</a:t>
             </a:fld>
             <a:endParaRPr lang="en-US"/>
           </a:p>
@@ -2912,7 +3049,7 @@
           <a:p>
             <a:fld id="{5D2A64DE-480B-420F-9649-4F8E696E08E0}" type="datetime1">
               <a:rPr lang="en-US" smtClean="0"/>
-              <a:t>3/29/2026</a:t>
+              <a:t>3/31/26</a:t>
             </a:fld>
             <a:endParaRPr lang="en-US"/>
           </a:p>
@@ -3236,7 +3373,7 @@
           <a:p>
             <a:fld id="{EA476A42-A091-4468-A075-64A31BE59948}" type="datetime1">
               <a:rPr lang="en-US" smtClean="0"/>
-              <a:t>3/29/2026</a:t>
+              <a:t>3/31/26</a:t>
             </a:fld>
             <a:endParaRPr lang="en-US"/>
           </a:p>
@@ -3434,7 +3571,7 @@
           <a:p>
             <a:fld id="{0D3616D0-8311-4107-9726-6B805E7D05BA}" type="datetime1">
               <a:rPr lang="en-US" smtClean="0"/>
-              <a:t>3/29/2026</a:t>
+              <a:t>3/31/26</a:t>
             </a:fld>
             <a:endParaRPr lang="en-US"/>
           </a:p>
@@ -3642,7 +3779,7 @@
           <a:p>
             <a:fld id="{3BC2557A-5C88-417A-A763-5AC779462A5F}" type="datetime1">
               <a:rPr lang="en-US" smtClean="0"/>
-              <a:t>3/29/2026</a:t>
+              <a:t>3/31/26</a:t>
             </a:fld>
             <a:endParaRPr lang="en-US"/>
           </a:p>
@@ -4166,7 +4303,7 @@
           <a:p>
             <a:fld id="{07C7BFD4-467E-4EDE-93EA-052F5B39A4E5}" type="datetime1">
               <a:rPr lang="en-US" smtClean="0"/>
-              <a:t>3/29/2026</a:t>
+              <a:t>3/31/26</a:t>
             </a:fld>
             <a:endParaRPr lang="en-US"/>
           </a:p>
@@ -4416,7 +4553,7 @@
           <a:p>
             <a:fld id="{07C7BFD4-467E-4EDE-93EA-052F5B39A4E5}" type="datetime1">
               <a:rPr lang="en-US" smtClean="0"/>
-              <a:t>3/29/2026</a:t>
+              <a:t>3/31/26</a:t>
             </a:fld>
             <a:endParaRPr lang="en-US"/>
           </a:p>
@@ -4598,7 +4735,7 @@
           <a:p>
             <a:fld id="{109E55A0-C911-4F03-82FC-7E5926047D46}" type="datetime1">
               <a:rPr lang="en-US" smtClean="0"/>
-              <a:t>3/29/2026</a:t>
+              <a:t>3/31/26</a:t>
             </a:fld>
             <a:endParaRPr lang="en-US"/>
           </a:p>
@@ -4911,7 +5048,7 @@
           <a:p>
             <a:fld id="{A533CBE2-D5BE-47AC-ADC2-9CDFC1D0CF90}" type="datetime1">
               <a:rPr lang="en-US" smtClean="0"/>
-              <a:t>3/29/2026</a:t>
+              <a:t>3/31/26</a:t>
             </a:fld>
             <a:endParaRPr lang="en-US"/>
           </a:p>
@@ -5212,7 +5349,7 @@
           <a:p>
             <a:fld id="{39B7EDB1-CE74-4951-85A2-0B01C2128E28}" type="datetime1">
               <a:rPr lang="en-US" smtClean="0"/>
-              <a:t>3/29/2026</a:t>
+              <a:t>3/31/26</a:t>
             </a:fld>
             <a:endParaRPr lang="en-US"/>
           </a:p>
@@ -5660,7 +5797,7 @@
           <a:p>
             <a:fld id="{2BC7EB92-A5C2-4807-A9DC-9EDE6CBFB241}" type="datetime1">
               <a:rPr lang="en-US" smtClean="0"/>
-              <a:t>3/29/2026</a:t>
+              <a:t>3/31/26</a:t>
             </a:fld>
             <a:endParaRPr lang="en-US"/>
           </a:p>
@@ -5773,7 +5910,7 @@
           <a:p>
             <a:fld id="{2B7B7EE0-7771-4CD5-9B2B-3550753A54A1}" type="datetime1">
               <a:rPr lang="en-US" smtClean="0"/>
-              <a:t>3/29/2026</a:t>
+              <a:t>3/31/26</a:t>
             </a:fld>
             <a:endParaRPr lang="en-US"/>
           </a:p>
@@ -6084,7 +6221,7 @@
           <a:p>
             <a:fld id="{F8B318B3-0E87-4416-A9B8-D891968C2727}" type="datetime1">
               <a:rPr lang="en-US" smtClean="0"/>
-              <a:t>3/29/2026</a:t>
+              <a:t>3/31/26</a:t>
             </a:fld>
             <a:endParaRPr lang="en-US"/>
           </a:p>
@@ -6325,7 +6462,7 @@
           <a:p>
             <a:fld id="{54D997E8-DDEE-43F1-8D9B-F8A1E11DE488}" type="datetime1">
               <a:rPr lang="en-US" smtClean="0"/>
-              <a:t>3/29/2026</a:t>
+              <a:t>3/31/26</a:t>
             </a:fld>
             <a:endParaRPr lang="en-US"/>
           </a:p>
@@ -17483,7 +17620,7 @@
           <p:cNvPr id="2" name="Title 1">
             <a:extLst>
               <a:ext uri="{FF2B5EF4-FFF2-40B4-BE49-F238E27FC236}">
-                <a16:creationId xmlns:a16="http://schemas.microsoft.com/office/drawing/2014/main" id="{3F922C6B-EDFC-20C4-8EB6-A70752B18E64}"/>
+                <a16:creationId xmlns:a16="http://schemas.microsoft.com/office/drawing/2014/main" id="{6ECCE0A9-D49A-C9A3-4D02-BE93F3D82363}"/>
               </a:ext>
             </a:extLst>
           </p:cNvPr>
@@ -17501,7 +17638,7 @@
           <a:p>
             <a:r>
               <a:rPr lang="en-US" dirty="0"/>
-              <a:t>4. A few words about AI traps</a:t>
+              <a:t>“Teams of agents”</a:t>
             </a:r>
           </a:p>
         </p:txBody>
@@ -17511,7 +17648,7 @@
           <p:cNvPr id="3" name="Content Placeholder 2">
             <a:extLst>
               <a:ext uri="{FF2B5EF4-FFF2-40B4-BE49-F238E27FC236}">
-                <a16:creationId xmlns:a16="http://schemas.microsoft.com/office/drawing/2014/main" id="{4FBF8BAD-DB4D-9083-C1CA-42E4FE997DEC}"/>
+                <a16:creationId xmlns:a16="http://schemas.microsoft.com/office/drawing/2014/main" id="{EA58A68B-D8E2-7052-7127-52886714C324}"/>
               </a:ext>
             </a:extLst>
           </p:cNvPr>
@@ -17522,12 +17659,71 @@
             <p:ph idx="1"/>
           </p:nvPr>
         </p:nvSpPr>
-        <p:spPr/>
+        <p:spPr>
+          <a:xfrm>
+            <a:off x="838200" y="1500160"/>
+            <a:ext cx="10967720" cy="5357840"/>
+          </a:xfrm>
+        </p:spPr>
         <p:txBody>
           <a:bodyPr/>
           <a:lstStyle/>
           <a:p>
-            <a:endParaRPr lang="en-US"/>
+            <a:r>
+              <a:rPr lang="en-US" dirty="0"/>
+              <a:t>So far in 2026, there have been some unhinged, heavily hyped versions of having different agents with different instructions working together. (Search for “Gas Town Yegge” at your own risk)</a:t>
+            </a:r>
+          </a:p>
+          <a:p>
+            <a:r>
+              <a:rPr lang="en-US" dirty="0"/>
+              <a:t>One of Prof Simmons’s colleagues at Lean FRO, Kim Morrison, </a:t>
+            </a:r>
+            <a:br>
+              <a:rPr lang="en-US" dirty="0"/>
+            </a:br>
+            <a:r>
+              <a:rPr lang="en-US" dirty="0"/>
+              <a:t>recently </a:t>
+            </a:r>
+            <a:br>
+              <a:rPr lang="en-US" dirty="0"/>
+            </a:br>
+            <a:r>
+              <a:rPr lang="en-US" dirty="0"/>
+              <a:t>demoed</a:t>
+            </a:r>
+            <a:br>
+              <a:rPr lang="en-US" dirty="0"/>
+            </a:br>
+            <a:r>
+              <a:rPr lang="en-US" dirty="0"/>
+              <a:t>a less unhinged</a:t>
+            </a:r>
+            <a:br>
+              <a:rPr lang="en-US" dirty="0"/>
+            </a:br>
+            <a:r>
+              <a:rPr lang="en-US" dirty="0"/>
+              <a:t>version of this</a:t>
+            </a:r>
+            <a:br>
+              <a:rPr lang="en-US" dirty="0"/>
+            </a:br>
+            <a:r>
+              <a:rPr lang="en-US" dirty="0"/>
+              <a:t>idea, shown</a:t>
+            </a:r>
+            <a:br>
+              <a:rPr lang="en-US" dirty="0"/>
+            </a:br>
+            <a:r>
+              <a:rPr lang="en-US" dirty="0"/>
+              <a:t>here.</a:t>
+            </a:r>
+          </a:p>
+          <a:p>
+            <a:endParaRPr lang="en-US" dirty="0"/>
           </a:p>
         </p:txBody>
       </p:sp>
@@ -17536,7 +17732,7 @@
           <p:cNvPr id="4" name="Slide Number Placeholder 3">
             <a:extLst>
               <a:ext uri="{FF2B5EF4-FFF2-40B4-BE49-F238E27FC236}">
-                <a16:creationId xmlns:a16="http://schemas.microsoft.com/office/drawing/2014/main" id="{628E6770-A7B8-FE51-E86F-5D8E4CF219A7}"/>
+                <a16:creationId xmlns:a16="http://schemas.microsoft.com/office/drawing/2014/main" id="{7E6D50D8-E273-4596-958D-1CEA0092E672}"/>
               </a:ext>
             </a:extLst>
           </p:cNvPr>
@@ -17560,10 +17756,47 @@
           </a:p>
         </p:txBody>
       </p:sp>
+      <p:pic>
+        <p:nvPicPr>
+          <p:cNvPr id="8" name="Picture 7">
+            <a:extLst>
+              <a:ext uri="{FF2B5EF4-FFF2-40B4-BE49-F238E27FC236}">
+                <a16:creationId xmlns:a16="http://schemas.microsoft.com/office/drawing/2014/main" id="{8263137E-10C0-6C04-2A99-02B67630297F}"/>
+              </a:ext>
+            </a:extLst>
+          </p:cNvPr>
+          <p:cNvPicPr>
+            <a:picLocks noChangeAspect="1"/>
+          </p:cNvPicPr>
+          <p:nvPr/>
+        </p:nvPicPr>
+        <p:blipFill>
+          <a:blip r:embed="rId3">
+            <a:extLst>
+              <a:ext uri="{28A0092B-C50C-407E-A947-70E740481C1C}">
+                <a14:useLocalDpi xmlns:a14="http://schemas.microsoft.com/office/drawing/2010/main" val="0"/>
+              </a:ext>
+            </a:extLst>
+          </a:blip>
+          <a:srcRect b="51531"/>
+          <a:stretch>
+            <a:fillRect/>
+          </a:stretch>
+        </p:blipFill>
+        <p:spPr>
+          <a:xfrm>
+            <a:off x="3484880" y="3204608"/>
+            <a:ext cx="11944466" cy="4306464"/>
+          </a:xfrm>
+          <a:prstGeom prst="rect">
+            <a:avLst/>
+          </a:prstGeom>
+        </p:spPr>
+      </p:pic>
     </p:spTree>
     <p:extLst>
       <p:ext uri="{BB962C8B-B14F-4D97-AF65-F5344CB8AC3E}">
-        <p14:creationId xmlns:p14="http://schemas.microsoft.com/office/powerpoint/2010/main" val="2982449787"/>
+        <p14:creationId xmlns:p14="http://schemas.microsoft.com/office/powerpoint/2010/main" val="1203449717"/>
       </p:ext>
     </p:extLst>
   </p:cSld>
@@ -17592,7 +17825,13 @@
       </p:grpSpPr>
       <p:sp>
         <p:nvSpPr>
-          <p:cNvPr id="2" name="Title 1"/>
+          <p:cNvPr id="2" name="Title 1">
+            <a:extLst>
+              <a:ext uri="{FF2B5EF4-FFF2-40B4-BE49-F238E27FC236}">
+                <a16:creationId xmlns:a16="http://schemas.microsoft.com/office/drawing/2014/main" id="{3F922C6B-EDFC-20C4-8EB6-A70752B18E64}"/>
+              </a:ext>
+            </a:extLst>
+          </p:cNvPr>
           <p:cNvSpPr>
             <a:spLocks noGrp="1"/>
           </p:cNvSpPr>
@@ -17602,21 +17841,25 @@
         </p:nvSpPr>
         <p:spPr/>
         <p:txBody>
-          <a:bodyPr>
-            <a:normAutofit/>
-          </a:bodyPr>
-          <a:lstStyle/>
-          <a:p>
-            <a:r>
-              <a:rPr lang="en-US" sz="3200" dirty="0"/>
-              <a:t>Trap #1: The “Vibe Coding” Trap</a:t>
-            </a:r>
-          </a:p>
-        </p:txBody>
-      </p:sp>
-      <p:sp>
-        <p:nvSpPr>
-          <p:cNvPr id="3" name="Content Placeholder 2"/>
+          <a:bodyPr/>
+          <a:lstStyle/>
+          <a:p>
+            <a:r>
+              <a:rPr lang="en-US" dirty="0"/>
+              <a:t>4. A few words about AI traps</a:t>
+            </a:r>
+          </a:p>
+        </p:txBody>
+      </p:sp>
+      <p:sp>
+        <p:nvSpPr>
+          <p:cNvPr id="3" name="Content Placeholder 2">
+            <a:extLst>
+              <a:ext uri="{FF2B5EF4-FFF2-40B4-BE49-F238E27FC236}">
+                <a16:creationId xmlns:a16="http://schemas.microsoft.com/office/drawing/2014/main" id="{4FBF8BAD-DB4D-9083-C1CA-42E4FE997DEC}"/>
+              </a:ext>
+            </a:extLst>
+          </p:cNvPr>
           <p:cNvSpPr>
             <a:spLocks noGrp="1"/>
           </p:cNvSpPr>
@@ -17626,64 +17869,22 @@
         </p:nvSpPr>
         <p:spPr/>
         <p:txBody>
-          <a:bodyPr>
-            <a:normAutofit fontScale="92500" lnSpcReduction="20000"/>
-          </a:bodyPr>
-          <a:lstStyle/>
-          <a:p>
-            <a:r>
-              <a:rPr lang="en-US" dirty="0"/>
-              <a:t>What is “vibe coding”?</a:t>
-            </a:r>
-          </a:p>
-          <a:p>
-            <a:pPr lvl="1"/>
-            <a:r>
-              <a:rPr lang="en-US" dirty="0"/>
-              <a:t>Evaluating only EXECUTION, not CODE. Ask AI to implement a feature. Run the app, see if it “works.” If error, describe the error to AI and repeat. Never actually read or understand the code.</a:t>
-            </a:r>
-          </a:p>
-          <a:p>
-            <a:r>
-              <a:rPr lang="en-US" dirty="0"/>
-              <a:t>Why it leads to collapse:</a:t>
-            </a:r>
-          </a:p>
-          <a:p>
-            <a:pPr lvl="1"/>
-            <a:r>
-              <a:rPr lang="en-US" dirty="0"/>
-              <a:t>No troubleshooting capability — you don’t understand what the code does</a:t>
-            </a:r>
-          </a:p>
-          <a:p>
-            <a:pPr lvl="1"/>
-            <a:r>
-              <a:rPr lang="en-US" dirty="0"/>
-              <a:t>Can’t provide effective feedback — you can only describe symptoms, not problems</a:t>
-            </a:r>
-          </a:p>
-          <a:p>
-            <a:pPr lvl="1"/>
-            <a:r>
-              <a:rPr lang="en-US" dirty="0"/>
-              <a:t>Brittle development — one change breaks everything and you don’t know why</a:t>
-            </a:r>
-          </a:p>
-          <a:p>
-            <a:r>
-              <a:rPr lang="en-US" dirty="0"/>
-              <a:t>To effectively use AI, you must be able to EVALUATE the code itself — not just “does it run?”</a:t>
-            </a:r>
-          </a:p>
-          <a:p>
-            <a:endParaRPr lang="en-US" dirty="0"/>
-          </a:p>
-        </p:txBody>
-      </p:sp>
-      <p:sp>
-        <p:nvSpPr>
-          <p:cNvPr id="4" name="Slide Number Placeholder 3"/>
+          <a:bodyPr/>
+          <a:lstStyle/>
+          <a:p>
+            <a:endParaRPr lang="en-US"/>
+          </a:p>
+        </p:txBody>
+      </p:sp>
+      <p:sp>
+        <p:nvSpPr>
+          <p:cNvPr id="4" name="Slide Number Placeholder 3">
+            <a:extLst>
+              <a:ext uri="{FF2B5EF4-FFF2-40B4-BE49-F238E27FC236}">
+                <a16:creationId xmlns:a16="http://schemas.microsoft.com/office/drawing/2014/main" id="{628E6770-A7B8-FE51-E86F-5D8E4CF219A7}"/>
+              </a:ext>
+            </a:extLst>
+          </p:cNvPr>
           <p:cNvSpPr>
             <a:spLocks noGrp="1"/>
           </p:cNvSpPr>
@@ -17705,6 +17906,11 @@
         </p:txBody>
       </p:sp>
     </p:spTree>
+    <p:extLst>
+      <p:ext uri="{BB962C8B-B14F-4D97-AF65-F5344CB8AC3E}">
+        <p14:creationId xmlns:p14="http://schemas.microsoft.com/office/powerpoint/2010/main" val="2982449787"/>
+      </p:ext>
+    </p:extLst>
   </p:cSld>
   <p:clrMapOvr>
     <a:masterClrMapping/>
@@ -17748,7 +17954,7 @@
           <a:p>
             <a:r>
               <a:rPr lang="en-US" sz="3200" dirty="0"/>
-              <a:t>Trap #2: AI Creates “Learning Debt” When Used Too Early</a:t>
+              <a:t>Trap #1: The “Vibe Coding” Trap</a:t>
             </a:r>
           </a:p>
         </p:txBody>
@@ -17766,62 +17972,57 @@
         <p:spPr/>
         <p:txBody>
           <a:bodyPr>
-            <a:normAutofit fontScale="92500"/>
+            <a:normAutofit fontScale="92500" lnSpcReduction="20000"/>
           </a:bodyPr>
           <a:lstStyle/>
           <a:p>
             <a:r>
-              <a:rPr lang="en-US" b="1" dirty="0"/>
-              <a:t>Path A — Learning First (recommended):</a:t>
+              <a:rPr lang="en-US" dirty="0"/>
+              <a:t>What is “vibe coding”?</a:t>
             </a:r>
           </a:p>
           <a:p>
             <a:pPr lvl="1"/>
             <a:r>
               <a:rPr lang="en-US" dirty="0"/>
-              <a:t>Manual coding, mistakes, understanding errors, building mental models. Slower at first.</a:t>
+              <a:t>Evaluating only EXECUTION, not CODE. Ask AI to implement a feature. Run the app, see if it “works.” If error, describe the error to AI and repeat. Never actually read or understand the code.</a:t>
+            </a:r>
+          </a:p>
+          <a:p>
+            <a:r>
+              <a:rPr lang="en-US" dirty="0"/>
+              <a:t>Why it leads to collapse:</a:t>
             </a:r>
           </a:p>
           <a:p>
             <a:pPr lvl="1"/>
             <a:r>
               <a:rPr lang="en-US" dirty="0"/>
-              <a:t>When you eventually use AI, you can evaluate and guide it effectively.</a:t>
+              <a:t>No troubleshooting capability — you don’t understand what the code does</a:t>
             </a:r>
           </a:p>
           <a:p>
             <a:pPr lvl="1"/>
             <a:r>
               <a:rPr lang="en-US" dirty="0"/>
-              <a:t>Solid foundation that supports long-term productivity growth.</a:t>
-            </a:r>
-          </a:p>
-          <a:p>
-            <a:r>
-              <a:rPr lang="en-US" b="1" dirty="0"/>
-              <a:t>Path B — AI First:</a:t>
+              <a:t>Can’t provide effective feedback — you can only describe symptoms, not problems</a:t>
             </a:r>
           </a:p>
           <a:p>
             <a:pPr lvl="1"/>
             <a:r>
               <a:rPr lang="en-US" dirty="0"/>
-              <a:t>Fast initial progress. But you never learn WHY the code works.</a:t>
-            </a:r>
-          </a:p>
-          <a:p>
-            <a:pPr lvl="1"/>
-            <a:r>
-              <a:rPr lang="en-US" dirty="0"/>
-              <a:t>When complex bugs hit, you’re stuck — you can’t even describe the problem to AI effectively.</a:t>
-            </a:r>
-          </a:p>
-          <a:p>
-            <a:pPr lvl="1"/>
-            <a:r>
-              <a:rPr lang="en-US" dirty="0"/>
-              <a:t>Productivity collapses and never recovers to Path A levels.</a:t>
-            </a:r>
+              <a:t>Brittle development — one change breaks everything and you don’t know why</a:t>
+            </a:r>
+          </a:p>
+          <a:p>
+            <a:r>
+              <a:rPr lang="en-US" dirty="0"/>
+              <a:t>To effectively use AI, you must be able to EVALUATE the code itself — not just “does it run?”</a:t>
+            </a:r>
+          </a:p>
+          <a:p>
+            <a:endParaRPr lang="en-US" dirty="0"/>
           </a:p>
         </p:txBody>
       </p:sp>
@@ -17875,13 +18076,7 @@
       </p:grpSpPr>
       <p:sp>
         <p:nvSpPr>
-          <p:cNvPr id="2" name="Title 1">
-            <a:extLst>
-              <a:ext uri="{FF2B5EF4-FFF2-40B4-BE49-F238E27FC236}">
-                <a16:creationId xmlns:a16="http://schemas.microsoft.com/office/drawing/2014/main" id="{D594D5D3-62C7-FC3A-5BF2-3B8E08DDA091}"/>
-              </a:ext>
-            </a:extLst>
-          </p:cNvPr>
+          <p:cNvPr id="2" name="Title 1"/>
           <p:cNvSpPr>
             <a:spLocks noGrp="1"/>
           </p:cNvSpPr>
@@ -17891,25 +18086,21 @@
         </p:nvSpPr>
         <p:spPr/>
         <p:txBody>
-          <a:bodyPr/>
-          <a:lstStyle/>
-          <a:p>
-            <a:r>
-              <a:rPr lang="en-US" dirty="0"/>
-              <a:t>A "learning-tax" strategy can help mitigate deskilling.</a:t>
-            </a:r>
-          </a:p>
-        </p:txBody>
-      </p:sp>
-      <p:sp>
-        <p:nvSpPr>
-          <p:cNvPr id="3" name="Content Placeholder 2">
-            <a:extLst>
-              <a:ext uri="{FF2B5EF4-FFF2-40B4-BE49-F238E27FC236}">
-                <a16:creationId xmlns:a16="http://schemas.microsoft.com/office/drawing/2014/main" id="{391A5C37-C6EC-6BD1-ED22-C0F09F2537F6}"/>
-              </a:ext>
-            </a:extLst>
-          </p:cNvPr>
+          <a:bodyPr>
+            <a:normAutofit/>
+          </a:bodyPr>
+          <a:lstStyle/>
+          <a:p>
+            <a:r>
+              <a:rPr lang="en-US" sz="3200" dirty="0"/>
+              <a:t>Trap #2: AI Creates “Learning Debt” When Used Too Early</a:t>
+            </a:r>
+          </a:p>
+        </p:txBody>
+      </p:sp>
+      <p:sp>
+        <p:nvSpPr>
+          <p:cNvPr id="3" name="Content Placeholder 2"/>
           <p:cNvSpPr>
             <a:spLocks noGrp="1"/>
           </p:cNvSpPr>
@@ -17919,37 +18110,69 @@
         </p:nvSpPr>
         <p:spPr/>
         <p:txBody>
-          <a:bodyPr/>
-          <a:lstStyle/>
-          <a:p>
-            <a:r>
-              <a:rPr lang="en-US" dirty="0"/>
-              <a:t>Adopt a “learning tax” strategy: deliberately choose to implement certain components manually, even when AI could generate them instantly.</a:t>
-            </a:r>
-          </a:p>
-          <a:p>
-            <a:r>
-              <a:rPr lang="en-US" dirty="0"/>
-              <a:t>Otherwise you won't recognize when the AI is screwing up!</a:t>
-            </a:r>
-          </a:p>
-          <a:p>
-            <a:r>
-              <a:rPr lang="en-US" dirty="0"/>
-              <a:t>The goal isn’t to code without AI or to use it for everything, but to maintain the expertise that makes you irreplaceable—the judgment, creativity, and deep understanding that transforms good code into great software. (--Jon Bell)</a:t>
-            </a:r>
-          </a:p>
-        </p:txBody>
-      </p:sp>
-      <p:sp>
-        <p:nvSpPr>
-          <p:cNvPr id="4" name="Slide Number Placeholder 3">
-            <a:extLst>
-              <a:ext uri="{FF2B5EF4-FFF2-40B4-BE49-F238E27FC236}">
-                <a16:creationId xmlns:a16="http://schemas.microsoft.com/office/drawing/2014/main" id="{B5A705CD-F17C-2935-2551-EF05FC294324}"/>
-              </a:ext>
-            </a:extLst>
-          </p:cNvPr>
+          <a:bodyPr>
+            <a:normAutofit fontScale="92500"/>
+          </a:bodyPr>
+          <a:lstStyle/>
+          <a:p>
+            <a:r>
+              <a:rPr lang="en-US" b="1" dirty="0"/>
+              <a:t>Path A — Learning First (recommended):</a:t>
+            </a:r>
+          </a:p>
+          <a:p>
+            <a:pPr lvl="1"/>
+            <a:r>
+              <a:rPr lang="en-US" dirty="0"/>
+              <a:t>Manual coding, mistakes, understanding errors, building mental models. Slower at first.</a:t>
+            </a:r>
+          </a:p>
+          <a:p>
+            <a:pPr lvl="1"/>
+            <a:r>
+              <a:rPr lang="en-US" dirty="0"/>
+              <a:t>When you eventually use AI, you can evaluate and guide it effectively.</a:t>
+            </a:r>
+          </a:p>
+          <a:p>
+            <a:pPr lvl="1"/>
+            <a:r>
+              <a:rPr lang="en-US" dirty="0"/>
+              <a:t>Solid foundation that supports long-term productivity growth.</a:t>
+            </a:r>
+          </a:p>
+          <a:p>
+            <a:r>
+              <a:rPr lang="en-US" b="1" dirty="0"/>
+              <a:t>Path B — AI First:</a:t>
+            </a:r>
+          </a:p>
+          <a:p>
+            <a:pPr lvl="1"/>
+            <a:r>
+              <a:rPr lang="en-US" dirty="0"/>
+              <a:t>Fast initial progress. But you never learn WHY the code works.</a:t>
+            </a:r>
+          </a:p>
+          <a:p>
+            <a:pPr lvl="1"/>
+            <a:r>
+              <a:rPr lang="en-US" dirty="0"/>
+              <a:t>When complex bugs hit, you’re stuck — you can’t even describe the problem to AI effectively.</a:t>
+            </a:r>
+          </a:p>
+          <a:p>
+            <a:pPr lvl="1"/>
+            <a:r>
+              <a:rPr lang="en-US" dirty="0"/>
+              <a:t>Productivity collapses and never recovers to Path A levels.</a:t>
+            </a:r>
+          </a:p>
+        </p:txBody>
+      </p:sp>
+      <p:sp>
+        <p:nvSpPr>
+          <p:cNvPr id="4" name="Slide Number Placeholder 3"/>
           <p:cNvSpPr>
             <a:spLocks noGrp="1"/>
           </p:cNvSpPr>
@@ -17965,6 +18188,128 @@
             <a:fld id="{20F37917-FD3A-4669-9018-DA04BCDD3D75}" type="slidenum">
               <a:rPr lang="en-US" smtClean="0"/>
               <a:t>47</a:t>
+            </a:fld>
+            <a:endParaRPr lang="en-US"/>
+          </a:p>
+        </p:txBody>
+      </p:sp>
+    </p:spTree>
+  </p:cSld>
+  <p:clrMapOvr>
+    <a:masterClrMapping/>
+  </p:clrMapOvr>
+</p:sld>
+</file>
+
+<file path=ppt/slides/slide48.xml><?xml version="1.0" encoding="utf-8"?>
+<p:sld xmlns:a="http://schemas.openxmlformats.org/drawingml/2006/main" xmlns:r="http://schemas.openxmlformats.org/officeDocument/2006/relationships" xmlns:p="http://schemas.openxmlformats.org/presentationml/2006/main">
+  <p:cSld>
+    <p:spTree>
+      <p:nvGrpSpPr>
+        <p:cNvPr id="1" name=""/>
+        <p:cNvGrpSpPr/>
+        <p:nvPr/>
+      </p:nvGrpSpPr>
+      <p:grpSpPr>
+        <a:xfrm>
+          <a:off x="0" y="0"/>
+          <a:ext cx="0" cy="0"/>
+          <a:chOff x="0" y="0"/>
+          <a:chExt cx="0" cy="0"/>
+        </a:xfrm>
+      </p:grpSpPr>
+      <p:sp>
+        <p:nvSpPr>
+          <p:cNvPr id="2" name="Title 1">
+            <a:extLst>
+              <a:ext uri="{FF2B5EF4-FFF2-40B4-BE49-F238E27FC236}">
+                <a16:creationId xmlns:a16="http://schemas.microsoft.com/office/drawing/2014/main" id="{D594D5D3-62C7-FC3A-5BF2-3B8E08DDA091}"/>
+              </a:ext>
+            </a:extLst>
+          </p:cNvPr>
+          <p:cNvSpPr>
+            <a:spLocks noGrp="1"/>
+          </p:cNvSpPr>
+          <p:nvPr>
+            <p:ph type="title"/>
+          </p:nvPr>
+        </p:nvSpPr>
+        <p:spPr/>
+        <p:txBody>
+          <a:bodyPr/>
+          <a:lstStyle/>
+          <a:p>
+            <a:r>
+              <a:rPr lang="en-US" dirty="0"/>
+              <a:t>A "learning-tax" strategy can help mitigate deskilling.</a:t>
+            </a:r>
+          </a:p>
+        </p:txBody>
+      </p:sp>
+      <p:sp>
+        <p:nvSpPr>
+          <p:cNvPr id="3" name="Content Placeholder 2">
+            <a:extLst>
+              <a:ext uri="{FF2B5EF4-FFF2-40B4-BE49-F238E27FC236}">
+                <a16:creationId xmlns:a16="http://schemas.microsoft.com/office/drawing/2014/main" id="{391A5C37-C6EC-6BD1-ED22-C0F09F2537F6}"/>
+              </a:ext>
+            </a:extLst>
+          </p:cNvPr>
+          <p:cNvSpPr>
+            <a:spLocks noGrp="1"/>
+          </p:cNvSpPr>
+          <p:nvPr>
+            <p:ph idx="1"/>
+          </p:nvPr>
+        </p:nvSpPr>
+        <p:spPr/>
+        <p:txBody>
+          <a:bodyPr/>
+          <a:lstStyle/>
+          <a:p>
+            <a:r>
+              <a:rPr lang="en-US" dirty="0"/>
+              <a:t>Adopt a “learning tax” strategy: deliberately choose to implement certain components manually, even when AI could generate them instantly.</a:t>
+            </a:r>
+          </a:p>
+          <a:p>
+            <a:r>
+              <a:rPr lang="en-US" dirty="0"/>
+              <a:t>Otherwise you won't recognize when the AI is screwing up!</a:t>
+            </a:r>
+          </a:p>
+          <a:p>
+            <a:r>
+              <a:rPr lang="en-US" dirty="0"/>
+              <a:t>The goal isn’t to code without AI or to use it for everything, but to maintain the expertise that makes you irreplaceable—the judgment, creativity, and deep understanding that transforms good code into great software. (--Jon Bell)</a:t>
+            </a:r>
+          </a:p>
+        </p:txBody>
+      </p:sp>
+      <p:sp>
+        <p:nvSpPr>
+          <p:cNvPr id="4" name="Slide Number Placeholder 3">
+            <a:extLst>
+              <a:ext uri="{FF2B5EF4-FFF2-40B4-BE49-F238E27FC236}">
+                <a16:creationId xmlns:a16="http://schemas.microsoft.com/office/drawing/2014/main" id="{B5A705CD-F17C-2935-2551-EF05FC294324}"/>
+              </a:ext>
+            </a:extLst>
+          </p:cNvPr>
+          <p:cNvSpPr>
+            <a:spLocks noGrp="1"/>
+          </p:cNvSpPr>
+          <p:nvPr>
+            <p:ph type="sldNum" sz="quarter" idx="12"/>
+          </p:nvPr>
+        </p:nvSpPr>
+        <p:spPr/>
+        <p:txBody>
+          <a:bodyPr/>
+          <a:lstStyle/>
+          <a:p>
+            <a:fld id="{20F37917-FD3A-4669-9018-DA04BCDD3D75}" type="slidenum">
+              <a:rPr lang="en-US" smtClean="0"/>
+              <a:t>48</a:t>
             </a:fld>
             <a:endParaRPr lang="en-US"/>
           </a:p>
@@ -17983,7 +18328,7 @@
 </p:sld>
 </file>
 
-<file path=ppt/slides/slide48.xml><?xml version="1.0" encoding="utf-8"?>
+<file path=ppt/slides/slide49.xml><?xml version="1.0" encoding="utf-8"?>
 <p:sld xmlns:a="http://schemas.openxmlformats.org/drawingml/2006/main" xmlns:r="http://schemas.openxmlformats.org/officeDocument/2006/relationships" xmlns:p="http://schemas.openxmlformats.org/presentationml/2006/main">
   <p:cSld>
     <p:spTree>
@@ -18126,7 +18471,7 @@
           <a:p>
             <a:fld id="{20F37917-FD3A-4669-9018-DA04BCDD3D75}" type="slidenum">
               <a:rPr lang="en-US" smtClean="0"/>
-              <a:t>48</a:t>
+              <a:t>49</a:t>
             </a:fld>
             <a:endParaRPr lang="en-US"/>
           </a:p>
@@ -18136,171 +18481,6 @@
     <p:extLst>
       <p:ext uri="{BB962C8B-B14F-4D97-AF65-F5344CB8AC3E}">
         <p14:creationId xmlns:p14="http://schemas.microsoft.com/office/powerpoint/2010/main" val="3373930033"/>
-      </p:ext>
-    </p:extLst>
-  </p:cSld>
-  <p:clrMapOvr>
-    <a:masterClrMapping/>
-  </p:clrMapOvr>
-</p:sld>
-</file>
-
-<file path=ppt/slides/slide49.xml><?xml version="1.0" encoding="utf-8"?>
-<p:sld xmlns:a="http://schemas.openxmlformats.org/drawingml/2006/main" xmlns:r="http://schemas.openxmlformats.org/officeDocument/2006/relationships" xmlns:p="http://schemas.openxmlformats.org/presentationml/2006/main">
-  <p:cSld>
-    <p:spTree>
-      <p:nvGrpSpPr>
-        <p:cNvPr id="1" name="">
-          <a:extLst>
-            <a:ext uri="{FF2B5EF4-FFF2-40B4-BE49-F238E27FC236}">
-              <a16:creationId xmlns:a16="http://schemas.microsoft.com/office/drawing/2014/main" id="{05A62C55-8B9A-4402-EC35-5B2F454B5559}"/>
-            </a:ext>
-          </a:extLst>
-        </p:cNvPr>
-        <p:cNvGrpSpPr/>
-        <p:nvPr/>
-      </p:nvGrpSpPr>
-      <p:grpSpPr>
-        <a:xfrm>
-          <a:off x="0" y="0"/>
-          <a:ext cx="0" cy="0"/>
-          <a:chOff x="0" y="0"/>
-          <a:chExt cx="0" cy="0"/>
-        </a:xfrm>
-      </p:grpSpPr>
-      <p:sp>
-        <p:nvSpPr>
-          <p:cNvPr id="2" name="Title 1">
-            <a:extLst>
-              <a:ext uri="{FF2B5EF4-FFF2-40B4-BE49-F238E27FC236}">
-                <a16:creationId xmlns:a16="http://schemas.microsoft.com/office/drawing/2014/main" id="{42FCDD3C-88B6-0675-D653-8D50068AF3F8}"/>
-              </a:ext>
-            </a:extLst>
-          </p:cNvPr>
-          <p:cNvSpPr>
-            <a:spLocks noGrp="1"/>
-          </p:cNvSpPr>
-          <p:nvPr>
-            <p:ph type="title"/>
-          </p:nvPr>
-        </p:nvSpPr>
-        <p:spPr/>
-        <p:txBody>
-          <a:bodyPr/>
-          <a:lstStyle/>
-          <a:p>
-            <a:r>
-              <a:rPr lang="en-US" dirty="0"/>
-              <a:t>Learning Goals for this Lesson</a:t>
-            </a:r>
-          </a:p>
-        </p:txBody>
-      </p:sp>
-      <p:sp>
-        <p:nvSpPr>
-          <p:cNvPr id="3" name="Content Placeholder 2">
-            <a:extLst>
-              <a:ext uri="{FF2B5EF4-FFF2-40B4-BE49-F238E27FC236}">
-                <a16:creationId xmlns:a16="http://schemas.microsoft.com/office/drawing/2014/main" id="{89E50DD1-372F-902B-0748-CC824B9F81EF}"/>
-              </a:ext>
-            </a:extLst>
-          </p:cNvPr>
-          <p:cNvSpPr>
-            <a:spLocks noGrp="1"/>
-          </p:cNvSpPr>
-          <p:nvPr>
-            <p:ph idx="1"/>
-          </p:nvPr>
-        </p:nvSpPr>
-        <p:spPr/>
-        <p:txBody>
-          <a:bodyPr>
-            <a:normAutofit/>
-          </a:bodyPr>
-          <a:lstStyle/>
-          <a:p>
-            <a:r>
-              <a:rPr lang="en-US" dirty="0"/>
-              <a:t>Now, at the end of this lesson, you should be able to</a:t>
-            </a:r>
-          </a:p>
-          <a:p>
-            <a:pPr lvl="1"/>
-            <a:r>
-              <a:rPr lang="en-US" dirty="0"/>
-              <a:t>Explain what an AI Coding Assistant is and is not</a:t>
-            </a:r>
-          </a:p>
-          <a:p>
-            <a:pPr lvl="1"/>
-            <a:r>
-              <a:rPr lang="en-US" dirty="0"/>
-              <a:t>Describe how to determine when using an AI assistant is or is not appropriate</a:t>
-            </a:r>
-          </a:p>
-          <a:p>
-            <a:pPr lvl="1"/>
-            <a:r>
-              <a:rPr lang="en-US" dirty="0"/>
-              <a:t>Explain the 6-step Human-AI Workflow pattern</a:t>
-            </a:r>
-          </a:p>
-          <a:p>
-            <a:pPr lvl="1"/>
-            <a:r>
-              <a:rPr lang="en-US" dirty="0"/>
-              <a:t>Explain the Plan-First pattern</a:t>
-            </a:r>
-          </a:p>
-          <a:p>
-            <a:pPr lvl="1"/>
-            <a:r>
-              <a:rPr lang="en-US" dirty="0"/>
-              <a:t>Explain the Prompt-Contract pattern</a:t>
-            </a:r>
-          </a:p>
-          <a:p>
-            <a:pPr lvl="1"/>
-            <a:r>
-              <a:rPr lang="en-US" dirty="0"/>
-              <a:t>Know how to avoid de-skilling</a:t>
-            </a:r>
-          </a:p>
-        </p:txBody>
-      </p:sp>
-      <p:sp>
-        <p:nvSpPr>
-          <p:cNvPr id="4" name="Slide Number Placeholder 3">
-            <a:extLst>
-              <a:ext uri="{FF2B5EF4-FFF2-40B4-BE49-F238E27FC236}">
-                <a16:creationId xmlns:a16="http://schemas.microsoft.com/office/drawing/2014/main" id="{D5E738B2-5A7C-C278-C294-5451ED30F746}"/>
-              </a:ext>
-            </a:extLst>
-          </p:cNvPr>
-          <p:cNvSpPr>
-            <a:spLocks noGrp="1"/>
-          </p:cNvSpPr>
-          <p:nvPr>
-            <p:ph type="sldNum" sz="quarter" idx="12"/>
-          </p:nvPr>
-        </p:nvSpPr>
-        <p:spPr/>
-        <p:txBody>
-          <a:bodyPr/>
-          <a:lstStyle/>
-          <a:p>
-            <a:fld id="{20F37917-FD3A-4669-9018-DA04BCDD3D75}" type="slidenum">
-              <a:rPr lang="en-US" smtClean="0"/>
-              <a:t>49</a:t>
-            </a:fld>
-            <a:endParaRPr lang="en-US"/>
-          </a:p>
-        </p:txBody>
-      </p:sp>
-    </p:spTree>
-    <p:extLst>
-      <p:ext uri="{BB962C8B-B14F-4D97-AF65-F5344CB8AC3E}">
-        <p14:creationId xmlns:p14="http://schemas.microsoft.com/office/powerpoint/2010/main" val="2411008161"/>
       </p:ext>
     </p:extLst>
   </p:cSld>
@@ -18457,6 +18637,171 @@
     <p:extLst>
       <p:ext uri="{BB962C8B-B14F-4D97-AF65-F5344CB8AC3E}">
         <p14:creationId xmlns:p14="http://schemas.microsoft.com/office/powerpoint/2010/main" val="704142156"/>
+      </p:ext>
+    </p:extLst>
+  </p:cSld>
+  <p:clrMapOvr>
+    <a:masterClrMapping/>
+  </p:clrMapOvr>
+</p:sld>
+</file>
+
+<file path=ppt/slides/slide50.xml><?xml version="1.0" encoding="utf-8"?>
+<p:sld xmlns:a="http://schemas.openxmlformats.org/drawingml/2006/main" xmlns:r="http://schemas.openxmlformats.org/officeDocument/2006/relationships" xmlns:p="http://schemas.openxmlformats.org/presentationml/2006/main">
+  <p:cSld>
+    <p:spTree>
+      <p:nvGrpSpPr>
+        <p:cNvPr id="1" name="">
+          <a:extLst>
+            <a:ext uri="{FF2B5EF4-FFF2-40B4-BE49-F238E27FC236}">
+              <a16:creationId xmlns:a16="http://schemas.microsoft.com/office/drawing/2014/main" id="{05A62C55-8B9A-4402-EC35-5B2F454B5559}"/>
+            </a:ext>
+          </a:extLst>
+        </p:cNvPr>
+        <p:cNvGrpSpPr/>
+        <p:nvPr/>
+      </p:nvGrpSpPr>
+      <p:grpSpPr>
+        <a:xfrm>
+          <a:off x="0" y="0"/>
+          <a:ext cx="0" cy="0"/>
+          <a:chOff x="0" y="0"/>
+          <a:chExt cx="0" cy="0"/>
+        </a:xfrm>
+      </p:grpSpPr>
+      <p:sp>
+        <p:nvSpPr>
+          <p:cNvPr id="2" name="Title 1">
+            <a:extLst>
+              <a:ext uri="{FF2B5EF4-FFF2-40B4-BE49-F238E27FC236}">
+                <a16:creationId xmlns:a16="http://schemas.microsoft.com/office/drawing/2014/main" id="{42FCDD3C-88B6-0675-D653-8D50068AF3F8}"/>
+              </a:ext>
+            </a:extLst>
+          </p:cNvPr>
+          <p:cNvSpPr>
+            <a:spLocks noGrp="1"/>
+          </p:cNvSpPr>
+          <p:nvPr>
+            <p:ph type="title"/>
+          </p:nvPr>
+        </p:nvSpPr>
+        <p:spPr/>
+        <p:txBody>
+          <a:bodyPr/>
+          <a:lstStyle/>
+          <a:p>
+            <a:r>
+              <a:rPr lang="en-US" dirty="0"/>
+              <a:t>Learning Goals for this Lesson</a:t>
+            </a:r>
+          </a:p>
+        </p:txBody>
+      </p:sp>
+      <p:sp>
+        <p:nvSpPr>
+          <p:cNvPr id="3" name="Content Placeholder 2">
+            <a:extLst>
+              <a:ext uri="{FF2B5EF4-FFF2-40B4-BE49-F238E27FC236}">
+                <a16:creationId xmlns:a16="http://schemas.microsoft.com/office/drawing/2014/main" id="{89E50DD1-372F-902B-0748-CC824B9F81EF}"/>
+              </a:ext>
+            </a:extLst>
+          </p:cNvPr>
+          <p:cNvSpPr>
+            <a:spLocks noGrp="1"/>
+          </p:cNvSpPr>
+          <p:nvPr>
+            <p:ph idx="1"/>
+          </p:nvPr>
+        </p:nvSpPr>
+        <p:spPr/>
+        <p:txBody>
+          <a:bodyPr>
+            <a:normAutofit/>
+          </a:bodyPr>
+          <a:lstStyle/>
+          <a:p>
+            <a:r>
+              <a:rPr lang="en-US" dirty="0"/>
+              <a:t>Now, at the end of this lesson, you should be able to</a:t>
+            </a:r>
+          </a:p>
+          <a:p>
+            <a:pPr lvl="1"/>
+            <a:r>
+              <a:rPr lang="en-US" dirty="0"/>
+              <a:t>Explain what an AI Coding Assistant is and is not</a:t>
+            </a:r>
+          </a:p>
+          <a:p>
+            <a:pPr lvl="1"/>
+            <a:r>
+              <a:rPr lang="en-US" dirty="0"/>
+              <a:t>Describe how to determine when using an AI assistant is or is not appropriate</a:t>
+            </a:r>
+          </a:p>
+          <a:p>
+            <a:pPr lvl="1"/>
+            <a:r>
+              <a:rPr lang="en-US" dirty="0"/>
+              <a:t>Explain the 6-step Human-AI Workflow pattern</a:t>
+            </a:r>
+          </a:p>
+          <a:p>
+            <a:pPr lvl="1"/>
+            <a:r>
+              <a:rPr lang="en-US" dirty="0"/>
+              <a:t>Explain the Plan-First pattern</a:t>
+            </a:r>
+          </a:p>
+          <a:p>
+            <a:pPr lvl="1"/>
+            <a:r>
+              <a:rPr lang="en-US" dirty="0"/>
+              <a:t>Explain the Prompt-Contract pattern</a:t>
+            </a:r>
+          </a:p>
+          <a:p>
+            <a:pPr lvl="1"/>
+            <a:r>
+              <a:rPr lang="en-US" dirty="0"/>
+              <a:t>Know how to avoid de-skilling</a:t>
+            </a:r>
+          </a:p>
+        </p:txBody>
+      </p:sp>
+      <p:sp>
+        <p:nvSpPr>
+          <p:cNvPr id="4" name="Slide Number Placeholder 3">
+            <a:extLst>
+              <a:ext uri="{FF2B5EF4-FFF2-40B4-BE49-F238E27FC236}">
+                <a16:creationId xmlns:a16="http://schemas.microsoft.com/office/drawing/2014/main" id="{D5E738B2-5A7C-C278-C294-5451ED30F746}"/>
+              </a:ext>
+            </a:extLst>
+          </p:cNvPr>
+          <p:cNvSpPr>
+            <a:spLocks noGrp="1"/>
+          </p:cNvSpPr>
+          <p:nvPr>
+            <p:ph type="sldNum" sz="quarter" idx="12"/>
+          </p:nvPr>
+        </p:nvSpPr>
+        <p:spPr/>
+        <p:txBody>
+          <a:bodyPr/>
+          <a:lstStyle/>
+          <a:p>
+            <a:fld id="{20F37917-FD3A-4669-9018-DA04BCDD3D75}" type="slidenum">
+              <a:rPr lang="en-US" smtClean="0"/>
+              <a:t>50</a:t>
+            </a:fld>
+            <a:endParaRPr lang="en-US"/>
+          </a:p>
+        </p:txBody>
+      </p:sp>
+    </p:spTree>
+    <p:extLst>
+      <p:ext uri="{BB962C8B-B14F-4D97-AF65-F5344CB8AC3E}">
+        <p14:creationId xmlns:p14="http://schemas.microsoft.com/office/powerpoint/2010/main" val="2411008161"/>
       </p:ext>
     </p:extLst>
   </p:cSld>

</xml_diff>

<commit_message>
shuffled a few slides
</commit_message>
<xml_diff>
--- a/Slides/Module 16 Using AI Agents.pptx
+++ b/Slides/Module 16 Using AI Agents.pptx
@@ -5,7 +5,7 @@
     <p:sldMasterId id="2147483648" r:id="rId1"/>
   </p:sldMasterIdLst>
   <p:notesMasterIdLst>
-    <p:notesMasterId r:id="rId45"/>
+    <p:notesMasterId r:id="rId46"/>
   </p:notesMasterIdLst>
   <p:sldIdLst>
     <p:sldId id="485" r:id="rId2"/>
@@ -39,35 +39,36 @@
     <p:sldId id="767" r:id="rId30"/>
     <p:sldId id="738" r:id="rId31"/>
     <p:sldId id="742" r:id="rId32"/>
-    <p:sldId id="770" r:id="rId33"/>
+    <p:sldId id="735" r:id="rId33"/>
     <p:sldId id="721" r:id="rId34"/>
-    <p:sldId id="735" r:id="rId35"/>
+    <p:sldId id="770" r:id="rId35"/>
     <p:sldId id="769" r:id="rId36"/>
     <p:sldId id="743" r:id="rId37"/>
     <p:sldId id="380" r:id="rId38"/>
-    <p:sldId id="761" r:id="rId39"/>
-    <p:sldId id="759" r:id="rId40"/>
-    <p:sldId id="621" r:id="rId41"/>
-    <p:sldId id="622" r:id="rId42"/>
-    <p:sldId id="744" r:id="rId43"/>
-    <p:sldId id="772" r:id="rId44"/>
+    <p:sldId id="773" r:id="rId39"/>
+    <p:sldId id="761" r:id="rId40"/>
+    <p:sldId id="759" r:id="rId41"/>
+    <p:sldId id="621" r:id="rId42"/>
+    <p:sldId id="622" r:id="rId43"/>
+    <p:sldId id="744" r:id="rId44"/>
+    <p:sldId id="772" r:id="rId45"/>
   </p:sldIdLst>
   <p:sldSz cx="12192000" cy="6858000"/>
   <p:notesSz cx="6858000" cy="9144000"/>
   <p:embeddedFontLst>
     <p:embeddedFont>
       <p:font typeface="Consolas" panose="020B0609020204030204" pitchFamily="49" charset="0"/>
-      <p:regular r:id="rId46"/>
-      <p:bold r:id="rId47"/>
-      <p:italic r:id="rId48"/>
-      <p:boldItalic r:id="rId49"/>
+      <p:regular r:id="rId47"/>
+      <p:bold r:id="rId48"/>
+      <p:italic r:id="rId49"/>
+      <p:boldItalic r:id="rId50"/>
     </p:embeddedFont>
     <p:embeddedFont>
       <p:font typeface="Verdana" panose="020B0604030504040204" pitchFamily="34" charset="0"/>
-      <p:regular r:id="rId50"/>
-      <p:bold r:id="rId51"/>
-      <p:italic r:id="rId52"/>
-      <p:boldItalic r:id="rId53"/>
+      <p:regular r:id="rId51"/>
+      <p:bold r:id="rId52"/>
+      <p:italic r:id="rId53"/>
+      <p:boldItalic r:id="rId54"/>
     </p:embeddedFont>
   </p:embeddedFontLst>
   <p:defaultTextStyle>
@@ -201,12 +202,13 @@
             <p14:sldId id="767"/>
             <p14:sldId id="738"/>
             <p14:sldId id="742"/>
+            <p14:sldId id="735"/>
+            <p14:sldId id="721"/>
             <p14:sldId id="770"/>
-            <p14:sldId id="721"/>
-            <p14:sldId id="735"/>
             <p14:sldId id="769"/>
             <p14:sldId id="743"/>
             <p14:sldId id="380"/>
+            <p14:sldId id="773"/>
             <p14:sldId id="761"/>
             <p14:sldId id="759"/>
             <p14:sldId id="621"/>
@@ -346,7 +348,7 @@
           <a:p>
             <a:fld id="{7C7E5181-6CF5-45F7-A87A-E0E0B1FD7549}" type="datetimeFigureOut">
               <a:rPr lang="en-US" smtClean="0"/>
-              <a:t>4/4/2026</a:t>
+              <a:t>4/9/2026</a:t>
             </a:fld>
             <a:endParaRPr lang="en-US"/>
           </a:p>
@@ -1893,10 +1895,7 @@
           <a:bodyPr/>
           <a:lstStyle/>
           <a:p>
-            <a:r>
-              <a:rPr lang="en-US" dirty="0"/>
-              <a:t>[Not sure whether this is the appropriate content or the appropriate placement for this slide]</a:t>
-            </a:r>
+            <a:endParaRPr lang="en-US" dirty="0"/>
           </a:p>
         </p:txBody>
       </p:sp>
@@ -1917,7 +1916,7 @@
           <a:p>
             <a:fld id="{07937F07-1250-4CCE-B198-1B2887014F41}" type="slidenum">
               <a:rPr lang="en-US" smtClean="0"/>
-              <a:t>32</a:t>
+              <a:t>33</a:t>
             </a:fld>
             <a:endParaRPr lang="en-US"/>
           </a:p>
@@ -1926,7 +1925,7 @@
     </p:spTree>
     <p:extLst>
       <p:ext uri="{BB962C8B-B14F-4D97-AF65-F5344CB8AC3E}">
-        <p14:creationId xmlns:p14="http://schemas.microsoft.com/office/powerpoint/2010/main" val="829265044"/>
+        <p14:creationId xmlns:p14="http://schemas.microsoft.com/office/powerpoint/2010/main" val="2056579705"/>
       </p:ext>
     </p:extLst>
   </p:cSld>
@@ -1982,7 +1981,7 @@
           <a:p>
             <a:r>
               <a:rPr lang="en-US" dirty="0"/>
-              <a:t>We've talked about "engagement"; now let's move to the "evaluation" part…</a:t>
+              <a:t>[Not sure whether this is the appropriate content or the appropriate placement for this slide]</a:t>
             </a:r>
           </a:p>
         </p:txBody>
@@ -2004,7 +2003,7 @@
           <a:p>
             <a:fld id="{07937F07-1250-4CCE-B198-1B2887014F41}" type="slidenum">
               <a:rPr lang="en-US" smtClean="0"/>
-              <a:t>33</a:t>
+              <a:t>34</a:t>
             </a:fld>
             <a:endParaRPr lang="en-US"/>
           </a:p>
@@ -2013,7 +2012,7 @@
     </p:spTree>
     <p:extLst>
       <p:ext uri="{BB962C8B-B14F-4D97-AF65-F5344CB8AC3E}">
-        <p14:creationId xmlns:p14="http://schemas.microsoft.com/office/powerpoint/2010/main" val="2056579705"/>
+        <p14:creationId xmlns:p14="http://schemas.microsoft.com/office/powerpoint/2010/main" val="829265044"/>
       </p:ext>
     </p:extLst>
   </p:cSld>
@@ -2319,7 +2318,7 @@
           <a:p>
             <a:fld id="{07937F07-1250-4CCE-B198-1B2887014F41}" type="slidenum">
               <a:rPr lang="en-US" smtClean="0"/>
-              <a:t>38</a:t>
+              <a:t>39</a:t>
             </a:fld>
             <a:endParaRPr lang="en-US"/>
           </a:p>
@@ -2403,7 +2402,7 @@
           <a:p>
             <a:fld id="{07937F07-1250-4CCE-B198-1B2887014F41}" type="slidenum">
               <a:rPr lang="en-US" smtClean="0"/>
-              <a:t>42</a:t>
+              <a:t>43</a:t>
             </a:fld>
             <a:endParaRPr lang="en-US"/>
           </a:p>
@@ -2558,7 +2557,7 @@
                 <a:tabLst/>
                 <a:defRPr/>
               </a:pPr>
-              <a:t>43</a:t>
+              <a:t>44</a:t>
             </a:fld>
             <a:endParaRPr kumimoji="0" lang="en-US" sz="1200" b="0" i="0" u="none" strike="noStrike" kern="1200" cap="none" spc="0" normalizeH="0" baseline="0" noProof="0">
               <a:ln>
@@ -3373,7 +3372,7 @@
           <a:p>
             <a:fld id="{5D2A64DE-480B-420F-9649-4F8E696E08E0}" type="datetime1">
               <a:rPr lang="en-US" smtClean="0"/>
-              <a:t>4/4/2026</a:t>
+              <a:t>4/9/2026</a:t>
             </a:fld>
             <a:endParaRPr lang="en-US"/>
           </a:p>
@@ -3697,7 +3696,7 @@
           <a:p>
             <a:fld id="{EA476A42-A091-4468-A075-64A31BE59948}" type="datetime1">
               <a:rPr lang="en-US" smtClean="0"/>
-              <a:t>4/4/2026</a:t>
+              <a:t>4/9/2026</a:t>
             </a:fld>
             <a:endParaRPr lang="en-US"/>
           </a:p>
@@ -3895,7 +3894,7 @@
           <a:p>
             <a:fld id="{0D3616D0-8311-4107-9726-6B805E7D05BA}" type="datetime1">
               <a:rPr lang="en-US" smtClean="0"/>
-              <a:t>4/4/2026</a:t>
+              <a:t>4/9/2026</a:t>
             </a:fld>
             <a:endParaRPr lang="en-US"/>
           </a:p>
@@ -4103,7 +4102,7 @@
           <a:p>
             <a:fld id="{3BC2557A-5C88-417A-A763-5AC779462A5F}" type="datetime1">
               <a:rPr lang="en-US" smtClean="0"/>
-              <a:t>4/4/2026</a:t>
+              <a:t>4/9/2026</a:t>
             </a:fld>
             <a:endParaRPr lang="en-US"/>
           </a:p>
@@ -4627,7 +4626,7 @@
           <a:p>
             <a:fld id="{07C7BFD4-467E-4EDE-93EA-052F5B39A4E5}" type="datetime1">
               <a:rPr lang="en-US" smtClean="0"/>
-              <a:t>4/4/2026</a:t>
+              <a:t>4/9/2026</a:t>
             </a:fld>
             <a:endParaRPr lang="en-US"/>
           </a:p>
@@ -4877,7 +4876,7 @@
           <a:p>
             <a:fld id="{07C7BFD4-467E-4EDE-93EA-052F5B39A4E5}" type="datetime1">
               <a:rPr lang="en-US" smtClean="0"/>
-              <a:t>4/4/2026</a:t>
+              <a:t>4/9/2026</a:t>
             </a:fld>
             <a:endParaRPr lang="en-US"/>
           </a:p>
@@ -5059,7 +5058,7 @@
           <a:p>
             <a:fld id="{109E55A0-C911-4F03-82FC-7E5926047D46}" type="datetime1">
               <a:rPr lang="en-US" smtClean="0"/>
-              <a:t>4/4/2026</a:t>
+              <a:t>4/9/2026</a:t>
             </a:fld>
             <a:endParaRPr lang="en-US"/>
           </a:p>
@@ -5372,7 +5371,7 @@
           <a:p>
             <a:fld id="{A533CBE2-D5BE-47AC-ADC2-9CDFC1D0CF90}" type="datetime1">
               <a:rPr lang="en-US" smtClean="0"/>
-              <a:t>4/4/2026</a:t>
+              <a:t>4/9/2026</a:t>
             </a:fld>
             <a:endParaRPr lang="en-US"/>
           </a:p>
@@ -5673,7 +5672,7 @@
           <a:p>
             <a:fld id="{39B7EDB1-CE74-4951-85A2-0B01C2128E28}" type="datetime1">
               <a:rPr lang="en-US" smtClean="0"/>
-              <a:t>4/4/2026</a:t>
+              <a:t>4/9/2026</a:t>
             </a:fld>
             <a:endParaRPr lang="en-US"/>
           </a:p>
@@ -6121,7 +6120,7 @@
           <a:p>
             <a:fld id="{2BC7EB92-A5C2-4807-A9DC-9EDE6CBFB241}" type="datetime1">
               <a:rPr lang="en-US" smtClean="0"/>
-              <a:t>4/4/2026</a:t>
+              <a:t>4/9/2026</a:t>
             </a:fld>
             <a:endParaRPr lang="en-US"/>
           </a:p>
@@ -6234,7 +6233,7 @@
           <a:p>
             <a:fld id="{2B7B7EE0-7771-4CD5-9B2B-3550753A54A1}" type="datetime1">
               <a:rPr lang="en-US" smtClean="0"/>
-              <a:t>4/4/2026</a:t>
+              <a:t>4/9/2026</a:t>
             </a:fld>
             <a:endParaRPr lang="en-US"/>
           </a:p>
@@ -6545,7 +6544,7 @@
           <a:p>
             <a:fld id="{F8B318B3-0E87-4416-A9B8-D891968C2727}" type="datetime1">
               <a:rPr lang="en-US" smtClean="0"/>
-              <a:t>4/4/2026</a:t>
+              <a:t>4/9/2026</a:t>
             </a:fld>
             <a:endParaRPr lang="en-US"/>
           </a:p>
@@ -6786,7 +6785,7 @@
           <a:p>
             <a:fld id="{54D997E8-DDEE-43F1-8D9B-F8A1E11DE488}" type="datetime1">
               <a:rPr lang="en-US" smtClean="0"/>
-              <a:t>4/4/2026</a:t>
+              <a:t>4/9/2026</a:t>
             </a:fld>
             <a:endParaRPr lang="en-US"/>
           </a:p>
@@ -14549,7 +14548,7 @@
           <p:cNvPr id="2" name="Title 1">
             <a:extLst>
               <a:ext uri="{FF2B5EF4-FFF2-40B4-BE49-F238E27FC236}">
-                <a16:creationId xmlns:a16="http://schemas.microsoft.com/office/drawing/2014/main" id="{8E92FD76-CE10-D3B0-9125-80BB39A4E112}"/>
+                <a16:creationId xmlns:a16="http://schemas.microsoft.com/office/drawing/2014/main" id="{03BD5A28-AD8F-D9A9-AEE8-01682F93F928}"/>
               </a:ext>
             </a:extLst>
           </p:cNvPr>
@@ -14567,7 +14566,7 @@
           <a:p>
             <a:r>
               <a:rPr lang="en-US" dirty="0"/>
-              <a:t>Another kind of engagement: Making sure the AI obeys the constraints</a:t>
+              <a:t>Step 3: Evaluation</a:t>
             </a:r>
           </a:p>
         </p:txBody>
@@ -14577,7 +14576,7 @@
           <p:cNvPr id="3" name="Content Placeholder 2">
             <a:extLst>
               <a:ext uri="{FF2B5EF4-FFF2-40B4-BE49-F238E27FC236}">
-                <a16:creationId xmlns:a16="http://schemas.microsoft.com/office/drawing/2014/main" id="{E349D3E3-04DA-EEE5-79E9-A3BAE378E128}"/>
+                <a16:creationId xmlns:a16="http://schemas.microsoft.com/office/drawing/2014/main" id="{290ED7E8-3C18-599D-F26A-1605F1D824E5}"/>
               </a:ext>
             </a:extLst>
           </p:cNvPr>
@@ -14595,38 +14594,19 @@
           <a:p>
             <a:r>
               <a:rPr lang="en-US" dirty="0"/>
-              <a:t>Run the AI in a sandbox, if you can</a:t>
-            </a:r>
-          </a:p>
-          <a:p>
-            <a:pPr lvl="1"/>
-            <a:r>
-              <a:rPr lang="en-US" dirty="0"/>
-              <a:t>to prevent it from deleting your emails, etc.</a:t>
-            </a:r>
-          </a:p>
-          <a:p>
-            <a:r>
-              <a:rPr lang="en-US" dirty="0"/>
-              <a:t>Remind it often about the constraints, so the constraints are always in context</a:t>
-            </a:r>
-          </a:p>
-          <a:p>
-            <a:r>
-              <a:rPr lang="en-US" dirty="0"/>
-              <a:t>Manual checking (at each step!)</a:t>
-            </a:r>
-          </a:p>
-          <a:p>
-            <a:r>
-              <a:rPr lang="en-US" dirty="0"/>
-              <a:t>Automated review by a separate AI</a:t>
-            </a:r>
-          </a:p>
-          <a:p>
-            <a:r>
-              <a:rPr lang="en-US" dirty="0"/>
-              <a:t>Refer to the onboarding guide of your AI for more specific advice.</a:t>
+              <a:t>You probably need a plan to do the evaluation</a:t>
+            </a:r>
+          </a:p>
+          <a:p>
+            <a:r>
+              <a:rPr lang="en-US" dirty="0"/>
+              <a:t>Assess AI outputs against expected results utilizing domain knowledge. </a:t>
+            </a:r>
+          </a:p>
+          <a:p>
+            <a:r>
+              <a:rPr lang="en-US" dirty="0"/>
+              <a:t>Compare output against expected end results and other success criteria.</a:t>
             </a:r>
           </a:p>
         </p:txBody>
@@ -14636,7 +14616,7 @@
           <p:cNvPr id="4" name="Slide Number Placeholder 3">
             <a:extLst>
               <a:ext uri="{FF2B5EF4-FFF2-40B4-BE49-F238E27FC236}">
-                <a16:creationId xmlns:a16="http://schemas.microsoft.com/office/drawing/2014/main" id="{4082C35C-FDA0-DD6B-DE07-FF741D160809}"/>
+                <a16:creationId xmlns:a16="http://schemas.microsoft.com/office/drawing/2014/main" id="{B402D061-2A18-B7F7-2B73-11D3EB76D128}"/>
               </a:ext>
             </a:extLst>
           </p:cNvPr>
@@ -14663,7 +14643,7 @@
     </p:spTree>
     <p:extLst>
       <p:ext uri="{BB962C8B-B14F-4D97-AF65-F5344CB8AC3E}">
-        <p14:creationId xmlns:p14="http://schemas.microsoft.com/office/powerpoint/2010/main" val="2398522231"/>
+        <p14:creationId xmlns:p14="http://schemas.microsoft.com/office/powerpoint/2010/main" val="2036297896"/>
       </p:ext>
     </p:extLst>
   </p:cSld>
@@ -14721,7 +14701,7 @@
           <a:p>
             <a:r>
               <a:rPr lang="en-US" dirty="0"/>
-              <a:t>Step 3, cont'd: Evaluate</a:t>
+              <a:t>Step 3: Evaluation, cont'd</a:t>
             </a:r>
           </a:p>
         </p:txBody>
@@ -14847,7 +14827,7 @@
           <p:cNvPr id="2" name="Title 1">
             <a:extLst>
               <a:ext uri="{FF2B5EF4-FFF2-40B4-BE49-F238E27FC236}">
-                <a16:creationId xmlns:a16="http://schemas.microsoft.com/office/drawing/2014/main" id="{03BD5A28-AD8F-D9A9-AEE8-01682F93F928}"/>
+                <a16:creationId xmlns:a16="http://schemas.microsoft.com/office/drawing/2014/main" id="{8E92FD76-CE10-D3B0-9125-80BB39A4E112}"/>
               </a:ext>
             </a:extLst>
           </p:cNvPr>
@@ -14865,7 +14845,7 @@
           <a:p>
             <a:r>
               <a:rPr lang="en-US" dirty="0"/>
-              <a:t>You probably need a plan to do the evaluation</a:t>
+              <a:t>Another kind of engagement: Making sure the AI obeys the constraints</a:t>
             </a:r>
           </a:p>
         </p:txBody>
@@ -14875,7 +14855,7 @@
           <p:cNvPr id="3" name="Content Placeholder 2">
             <a:extLst>
               <a:ext uri="{FF2B5EF4-FFF2-40B4-BE49-F238E27FC236}">
-                <a16:creationId xmlns:a16="http://schemas.microsoft.com/office/drawing/2014/main" id="{290ED7E8-3C18-599D-F26A-1605F1D824E5}"/>
+                <a16:creationId xmlns:a16="http://schemas.microsoft.com/office/drawing/2014/main" id="{E349D3E3-04DA-EEE5-79E9-A3BAE378E128}"/>
               </a:ext>
             </a:extLst>
           </p:cNvPr>
@@ -14893,13 +14873,38 @@
           <a:p>
             <a:r>
               <a:rPr lang="en-US" dirty="0"/>
-              <a:t>Assess AI outputs against expected results utilizing domain knowledge. </a:t>
-            </a:r>
-          </a:p>
-          <a:p>
-            <a:r>
-              <a:rPr lang="en-US" dirty="0"/>
-              <a:t>Compare output against expected end results and other success criteria.</a:t>
+              <a:t>Run the AI in a sandbox, if you can</a:t>
+            </a:r>
+          </a:p>
+          <a:p>
+            <a:pPr lvl="1"/>
+            <a:r>
+              <a:rPr lang="en-US" dirty="0"/>
+              <a:t>to prevent it from deleting your emails, etc.</a:t>
+            </a:r>
+          </a:p>
+          <a:p>
+            <a:r>
+              <a:rPr lang="en-US" dirty="0"/>
+              <a:t>Remind it often about the constraints, so the constraints are always in context</a:t>
+            </a:r>
+          </a:p>
+          <a:p>
+            <a:r>
+              <a:rPr lang="en-US" dirty="0"/>
+              <a:t>Manual checking (at each step!)</a:t>
+            </a:r>
+          </a:p>
+          <a:p>
+            <a:r>
+              <a:rPr lang="en-US" dirty="0"/>
+              <a:t>Automated review by a separate AI</a:t>
+            </a:r>
+          </a:p>
+          <a:p>
+            <a:r>
+              <a:rPr lang="en-US" dirty="0"/>
+              <a:t>Refer to the onboarding guide of your AI for more specific advice.</a:t>
             </a:r>
           </a:p>
         </p:txBody>
@@ -14909,7 +14914,7 @@
           <p:cNvPr id="4" name="Slide Number Placeholder 3">
             <a:extLst>
               <a:ext uri="{FF2B5EF4-FFF2-40B4-BE49-F238E27FC236}">
-                <a16:creationId xmlns:a16="http://schemas.microsoft.com/office/drawing/2014/main" id="{B402D061-2A18-B7F7-2B73-11D3EB76D128}"/>
+                <a16:creationId xmlns:a16="http://schemas.microsoft.com/office/drawing/2014/main" id="{4082C35C-FDA0-DD6B-DE07-FF741D160809}"/>
               </a:ext>
             </a:extLst>
           </p:cNvPr>
@@ -14936,7 +14941,7 @@
     </p:spTree>
     <p:extLst>
       <p:ext uri="{BB962C8B-B14F-4D97-AF65-F5344CB8AC3E}">
-        <p14:creationId xmlns:p14="http://schemas.microsoft.com/office/powerpoint/2010/main" val="2036297896"/>
+        <p14:creationId xmlns:p14="http://schemas.microsoft.com/office/powerpoint/2010/main" val="2398522231"/>
       </p:ext>
     </p:extLst>
   </p:cSld>
@@ -15903,7 +15908,7 @@
           <p:cNvPr id="2" name="Title 1">
             <a:extLst>
               <a:ext uri="{FF2B5EF4-FFF2-40B4-BE49-F238E27FC236}">
-                <a16:creationId xmlns:a16="http://schemas.microsoft.com/office/drawing/2014/main" id="{6ECCE0A9-D49A-C9A3-4D02-BE93F3D82363}"/>
+                <a16:creationId xmlns:a16="http://schemas.microsoft.com/office/drawing/2014/main" id="{D7A900ED-A49C-5CDB-5072-12E591E2AD06}"/>
               </a:ext>
             </a:extLst>
           </p:cNvPr>
@@ -15921,7 +15926,7 @@
           <a:p>
             <a:r>
               <a:rPr lang="en-US" dirty="0"/>
-              <a:t>The future of H/AI workflows: “Teams of agents”??</a:t>
+              <a:t>In the future: turn workflow steps into saved task prompts?</a:t>
             </a:r>
           </a:p>
         </p:txBody>
@@ -15931,7 +15936,7 @@
           <p:cNvPr id="3" name="Content Placeholder 2">
             <a:extLst>
               <a:ext uri="{FF2B5EF4-FFF2-40B4-BE49-F238E27FC236}">
-                <a16:creationId xmlns:a16="http://schemas.microsoft.com/office/drawing/2014/main" id="{EA58A68B-D8E2-7052-7127-52886714C324}"/>
+                <a16:creationId xmlns:a16="http://schemas.microsoft.com/office/drawing/2014/main" id="{FC1E1230-2F5D-E1F6-F48F-CB9E27EE5C55}"/>
               </a:ext>
             </a:extLst>
           </p:cNvPr>
@@ -15945,7 +15950,7 @@
         <p:spPr>
           <a:xfrm>
             <a:off x="838200" y="1500160"/>
-            <a:ext cx="10967720" cy="5357840"/>
+            <a:ext cx="5576455" cy="4351338"/>
           </a:xfrm>
         </p:spPr>
         <p:txBody>
@@ -15954,47 +15959,14 @@
           <a:p>
             <a:r>
               <a:rPr lang="en-US" dirty="0"/>
-              <a:t>So far in 2026, there have been some unhinged, heavily hyped versions of having different agents with different instructions working together. (Search for “Gas Town Yegge” at your own risk)</a:t>
-            </a:r>
-          </a:p>
-          <a:p>
-            <a:r>
-              <a:rPr lang="en-US" dirty="0"/>
-              <a:t>One of Prof Simmons’s colleagues at Lean FRO, Kim Morrison, </a:t>
-            </a:r>
-            <a:br>
-              <a:rPr lang="en-US" dirty="0"/>
-            </a:br>
-            <a:r>
-              <a:rPr lang="en-US" dirty="0"/>
-              <a:t>recently demoed a less unhinged version of this idea. </a:t>
-            </a:r>
-          </a:p>
-          <a:p>
-            <a:r>
-              <a:rPr lang="en-US" dirty="0"/>
-              <a:t>Nobody at present thinks this kind of workflow produces good software engineering — software maintainable </a:t>
-            </a:r>
-            <a:r>
-              <a:rPr lang="en-US" i="1" dirty="0"/>
-              <a:t>over time</a:t>
-            </a:r>
-            <a:r>
-              <a:rPr lang="en-US" dirty="0"/>
-              <a:t> — but it is demonstrably better at doing certain goal-oriented complex tasks (like searching for bugs in a compiler).</a:t>
-            </a:r>
-          </a:p>
-          <a:p>
-            <a:endParaRPr lang="en-US" dirty="0"/>
-          </a:p>
-          <a:p>
-            <a:endParaRPr lang="en-US" dirty="0"/>
-          </a:p>
-          <a:p>
-            <a:endParaRPr lang="en-US" dirty="0"/>
-          </a:p>
-          <a:p>
-            <a:endParaRPr lang="en-US" dirty="0"/>
+              <a:t>Here's an example where somebody has written out the details of the workflow steps as task prompts</a:t>
+            </a:r>
+          </a:p>
+          <a:p>
+            <a:r>
+              <a:rPr lang="en-US" dirty="0"/>
+              <a:t>Here expressed as Claude slash-commands</a:t>
+            </a:r>
           </a:p>
         </p:txBody>
       </p:sp>
@@ -16003,7 +15975,7 @@
           <p:cNvPr id="4" name="Slide Number Placeholder 3">
             <a:extLst>
               <a:ext uri="{FF2B5EF4-FFF2-40B4-BE49-F238E27FC236}">
-                <a16:creationId xmlns:a16="http://schemas.microsoft.com/office/drawing/2014/main" id="{7E6D50D8-E273-4596-958D-1CEA0092E672}"/>
+                <a16:creationId xmlns:a16="http://schemas.microsoft.com/office/drawing/2014/main" id="{1E6CD5FF-DCA2-D1E7-7D38-8435CA152249}"/>
               </a:ext>
             </a:extLst>
           </p:cNvPr>
@@ -16027,10 +15999,40 @@
           </a:p>
         </p:txBody>
       </p:sp>
+      <p:pic>
+        <p:nvPicPr>
+          <p:cNvPr id="6" name="Picture 5">
+            <a:extLst>
+              <a:ext uri="{FF2B5EF4-FFF2-40B4-BE49-F238E27FC236}">
+                <a16:creationId xmlns:a16="http://schemas.microsoft.com/office/drawing/2014/main" id="{E3343C75-494C-321B-62CA-3BBD9FA73C9C}"/>
+              </a:ext>
+            </a:extLst>
+          </p:cNvPr>
+          <p:cNvPicPr>
+            <a:picLocks noChangeAspect="1"/>
+          </p:cNvPicPr>
+          <p:nvPr/>
+        </p:nvPicPr>
+        <p:blipFill>
+          <a:blip r:embed="rId2"/>
+          <a:stretch>
+            <a:fillRect/>
+          </a:stretch>
+        </p:blipFill>
+        <p:spPr>
+          <a:xfrm>
+            <a:off x="6705601" y="1500160"/>
+            <a:ext cx="4648199" cy="11035292"/>
+          </a:xfrm>
+          <a:prstGeom prst="rect">
+            <a:avLst/>
+          </a:prstGeom>
+        </p:spPr>
+      </p:pic>
     </p:spTree>
     <p:extLst>
       <p:ext uri="{BB962C8B-B14F-4D97-AF65-F5344CB8AC3E}">
-        <p14:creationId xmlns:p14="http://schemas.microsoft.com/office/powerpoint/2010/main" val="1203449717"/>
+        <p14:creationId xmlns:p14="http://schemas.microsoft.com/office/powerpoint/2010/main" val="1826540473"/>
       </p:ext>
     </p:extLst>
   </p:cSld>
@@ -16062,7 +16064,7 @@
           <p:cNvPr id="2" name="Title 1">
             <a:extLst>
               <a:ext uri="{FF2B5EF4-FFF2-40B4-BE49-F238E27FC236}">
-                <a16:creationId xmlns:a16="http://schemas.microsoft.com/office/drawing/2014/main" id="{3F922C6B-EDFC-20C4-8EB6-A70752B18E64}"/>
+                <a16:creationId xmlns:a16="http://schemas.microsoft.com/office/drawing/2014/main" id="{6ECCE0A9-D49A-C9A3-4D02-BE93F3D82363}"/>
               </a:ext>
             </a:extLst>
           </p:cNvPr>
@@ -16080,7 +16082,7 @@
           <a:p>
             <a:r>
               <a:rPr lang="en-US" dirty="0"/>
-              <a:t>4. A few words about AI traps</a:t>
+              <a:t>In the future: teams of agents?</a:t>
             </a:r>
           </a:p>
         </p:txBody>
@@ -16090,7 +16092,7 @@
           <p:cNvPr id="3" name="Content Placeholder 2">
             <a:extLst>
               <a:ext uri="{FF2B5EF4-FFF2-40B4-BE49-F238E27FC236}">
-                <a16:creationId xmlns:a16="http://schemas.microsoft.com/office/drawing/2014/main" id="{4FBF8BAD-DB4D-9083-C1CA-42E4FE997DEC}"/>
+                <a16:creationId xmlns:a16="http://schemas.microsoft.com/office/drawing/2014/main" id="{EA58A68B-D8E2-7052-7127-52886714C324}"/>
               </a:ext>
             </a:extLst>
           </p:cNvPr>
@@ -16101,12 +16103,59 @@
             <p:ph idx="1"/>
           </p:nvPr>
         </p:nvSpPr>
-        <p:spPr/>
-        <p:txBody>
-          <a:bodyPr/>
-          <a:lstStyle/>
-          <a:p>
-            <a:endParaRPr lang="en-US"/>
+        <p:spPr>
+          <a:xfrm>
+            <a:off x="838200" y="1500160"/>
+            <a:ext cx="10967720" cy="5357840"/>
+          </a:xfrm>
+        </p:spPr>
+        <p:txBody>
+          <a:bodyPr/>
+          <a:lstStyle/>
+          <a:p>
+            <a:r>
+              <a:rPr lang="en-US" dirty="0"/>
+              <a:t>So far in 2026, there have been some unhinged, heavily hyped versions of having different agents with different instructions working together. (Search for “Gas Town Yegge” at your own risk)</a:t>
+            </a:r>
+          </a:p>
+          <a:p>
+            <a:r>
+              <a:rPr lang="en-US" dirty="0"/>
+              <a:t>One of Prof Simmons’s colleagues at Lean FRO, Kim Morrison, </a:t>
+            </a:r>
+            <a:br>
+              <a:rPr lang="en-US" dirty="0"/>
+            </a:br>
+            <a:r>
+              <a:rPr lang="en-US" dirty="0"/>
+              <a:t>recently demoed a less unhinged version of this idea. </a:t>
+            </a:r>
+          </a:p>
+          <a:p>
+            <a:r>
+              <a:rPr lang="en-US" dirty="0"/>
+              <a:t>Nobody at present thinks this kind of workflow produces good software engineering — software maintainable </a:t>
+            </a:r>
+            <a:r>
+              <a:rPr lang="en-US" i="1" dirty="0"/>
+              <a:t>over time</a:t>
+            </a:r>
+            <a:r>
+              <a:rPr lang="en-US" dirty="0"/>
+              <a:t> — but it is demonstrably better at doing certain goal-oriented complex tasks (like searching for bugs in a compiler).</a:t>
+            </a:r>
+          </a:p>
+          <a:p>
+            <a:endParaRPr lang="en-US" dirty="0"/>
+          </a:p>
+          <a:p>
+            <a:endParaRPr lang="en-US" dirty="0"/>
+          </a:p>
+          <a:p>
+            <a:endParaRPr lang="en-US" dirty="0"/>
+          </a:p>
+          <a:p>
+            <a:endParaRPr lang="en-US" dirty="0"/>
           </a:p>
         </p:txBody>
       </p:sp>
@@ -16115,7 +16164,7 @@
           <p:cNvPr id="4" name="Slide Number Placeholder 3">
             <a:extLst>
               <a:ext uri="{FF2B5EF4-FFF2-40B4-BE49-F238E27FC236}">
-                <a16:creationId xmlns:a16="http://schemas.microsoft.com/office/drawing/2014/main" id="{628E6770-A7B8-FE51-E86F-5D8E4CF219A7}"/>
+                <a16:creationId xmlns:a16="http://schemas.microsoft.com/office/drawing/2014/main" id="{7E6D50D8-E273-4596-958D-1CEA0092E672}"/>
               </a:ext>
             </a:extLst>
           </p:cNvPr>
@@ -16142,7 +16191,7 @@
     </p:spTree>
     <p:extLst>
       <p:ext uri="{BB962C8B-B14F-4D97-AF65-F5344CB8AC3E}">
-        <p14:creationId xmlns:p14="http://schemas.microsoft.com/office/powerpoint/2010/main" val="2982449787"/>
+        <p14:creationId xmlns:p14="http://schemas.microsoft.com/office/powerpoint/2010/main" val="1203449717"/>
       </p:ext>
     </p:extLst>
   </p:cSld>
@@ -16425,7 +16474,13 @@
       </p:grpSpPr>
       <p:sp>
         <p:nvSpPr>
-          <p:cNvPr id="2" name="Title 1"/>
+          <p:cNvPr id="2" name="Title 1">
+            <a:extLst>
+              <a:ext uri="{FF2B5EF4-FFF2-40B4-BE49-F238E27FC236}">
+                <a16:creationId xmlns:a16="http://schemas.microsoft.com/office/drawing/2014/main" id="{3F922C6B-EDFC-20C4-8EB6-A70752B18E64}"/>
+              </a:ext>
+            </a:extLst>
+          </p:cNvPr>
           <p:cNvSpPr>
             <a:spLocks noGrp="1"/>
           </p:cNvSpPr>
@@ -16435,21 +16490,25 @@
         </p:nvSpPr>
         <p:spPr/>
         <p:txBody>
-          <a:bodyPr>
-            <a:normAutofit/>
-          </a:bodyPr>
-          <a:lstStyle/>
-          <a:p>
-            <a:r>
-              <a:rPr lang="en-US" sz="3200" dirty="0"/>
-              <a:t>Trap #1: The “Vibe Coding” Trap</a:t>
-            </a:r>
-          </a:p>
-        </p:txBody>
-      </p:sp>
-      <p:sp>
-        <p:nvSpPr>
-          <p:cNvPr id="3" name="Content Placeholder 2"/>
+          <a:bodyPr/>
+          <a:lstStyle/>
+          <a:p>
+            <a:r>
+              <a:rPr lang="en-US" dirty="0"/>
+              <a:t>4. A few words about AI traps</a:t>
+            </a:r>
+          </a:p>
+        </p:txBody>
+      </p:sp>
+      <p:sp>
+        <p:nvSpPr>
+          <p:cNvPr id="3" name="Content Placeholder 2">
+            <a:extLst>
+              <a:ext uri="{FF2B5EF4-FFF2-40B4-BE49-F238E27FC236}">
+                <a16:creationId xmlns:a16="http://schemas.microsoft.com/office/drawing/2014/main" id="{4FBF8BAD-DB4D-9083-C1CA-42E4FE997DEC}"/>
+              </a:ext>
+            </a:extLst>
+          </p:cNvPr>
           <p:cNvSpPr>
             <a:spLocks noGrp="1"/>
           </p:cNvSpPr>
@@ -16459,64 +16518,22 @@
         </p:nvSpPr>
         <p:spPr/>
         <p:txBody>
-          <a:bodyPr>
-            <a:normAutofit fontScale="92500" lnSpcReduction="20000"/>
-          </a:bodyPr>
-          <a:lstStyle/>
-          <a:p>
-            <a:r>
-              <a:rPr lang="en-US" dirty="0"/>
-              <a:t>What is “vibe coding”?</a:t>
-            </a:r>
-          </a:p>
-          <a:p>
-            <a:pPr lvl="1"/>
-            <a:r>
-              <a:rPr lang="en-US" dirty="0"/>
-              <a:t>Evaluating only execution, not code. Ask AI to implement a feature. Run the app, see if it “works.” If error, describe the error to AI and repeat. Never actually read or understand the code.</a:t>
-            </a:r>
-          </a:p>
-          <a:p>
-            <a:r>
-              <a:rPr lang="en-US" dirty="0"/>
-              <a:t>Why it leads to collapse:</a:t>
-            </a:r>
-          </a:p>
-          <a:p>
-            <a:pPr lvl="1"/>
-            <a:r>
-              <a:rPr lang="en-US" dirty="0"/>
-              <a:t>No troubleshooting capability — you don’t understand what the code does</a:t>
-            </a:r>
-          </a:p>
-          <a:p>
-            <a:pPr lvl="1"/>
-            <a:r>
-              <a:rPr lang="en-US" dirty="0"/>
-              <a:t>Can’t provide effective feedback — you can only describe symptoms, not problems</a:t>
-            </a:r>
-          </a:p>
-          <a:p>
-            <a:pPr lvl="1"/>
-            <a:r>
-              <a:rPr lang="en-US" dirty="0"/>
-              <a:t>Brittle development — one change breaks everything and you don’t know why</a:t>
-            </a:r>
-          </a:p>
-          <a:p>
-            <a:r>
-              <a:rPr lang="en-US" dirty="0"/>
-              <a:t>To effectively use AI, you must be able to evaluate the code itself — not just “does it run?”</a:t>
-            </a:r>
-          </a:p>
-          <a:p>
-            <a:endParaRPr lang="en-US" dirty="0"/>
-          </a:p>
-        </p:txBody>
-      </p:sp>
-      <p:sp>
-        <p:nvSpPr>
-          <p:cNvPr id="4" name="Slide Number Placeholder 3"/>
+          <a:bodyPr/>
+          <a:lstStyle/>
+          <a:p>
+            <a:endParaRPr lang="en-US"/>
+          </a:p>
+        </p:txBody>
+      </p:sp>
+      <p:sp>
+        <p:nvSpPr>
+          <p:cNvPr id="4" name="Slide Number Placeholder 3">
+            <a:extLst>
+              <a:ext uri="{FF2B5EF4-FFF2-40B4-BE49-F238E27FC236}">
+                <a16:creationId xmlns:a16="http://schemas.microsoft.com/office/drawing/2014/main" id="{628E6770-A7B8-FE51-E86F-5D8E4CF219A7}"/>
+              </a:ext>
+            </a:extLst>
+          </p:cNvPr>
           <p:cNvSpPr>
             <a:spLocks noGrp="1"/>
           </p:cNvSpPr>
@@ -16538,6 +16555,11 @@
         </p:txBody>
       </p:sp>
     </p:spTree>
+    <p:extLst>
+      <p:ext uri="{BB962C8B-B14F-4D97-AF65-F5344CB8AC3E}">
+        <p14:creationId xmlns:p14="http://schemas.microsoft.com/office/powerpoint/2010/main" val="2982449787"/>
+      </p:ext>
+    </p:extLst>
   </p:cSld>
   <p:clrMapOvr>
     <a:masterClrMapping/>
@@ -16581,7 +16603,7 @@
           <a:p>
             <a:r>
               <a:rPr lang="en-US" sz="3200" dirty="0"/>
-              <a:t>Trap #2: AI Creates “Learning Debt” When Used Too Early</a:t>
+              <a:t>Trap #1: The “Vibe Coding” Trap</a:t>
             </a:r>
           </a:p>
         </p:txBody>
@@ -16599,62 +16621,57 @@
         <p:spPr/>
         <p:txBody>
           <a:bodyPr>
-            <a:normAutofit fontScale="92500"/>
+            <a:normAutofit fontScale="92500" lnSpcReduction="20000"/>
           </a:bodyPr>
           <a:lstStyle/>
           <a:p>
             <a:r>
-              <a:rPr lang="en-US" b="1" dirty="0"/>
-              <a:t>Path A — Learning First (recommended):</a:t>
+              <a:rPr lang="en-US" dirty="0"/>
+              <a:t>What is “vibe coding”?</a:t>
             </a:r>
           </a:p>
           <a:p>
             <a:pPr lvl="1"/>
             <a:r>
               <a:rPr lang="en-US" dirty="0"/>
-              <a:t>Manual coding, mistakes, understanding errors, building mental models. Slower at first.</a:t>
+              <a:t>Evaluating only execution, not code. Ask AI to implement a feature. Run the app, see if it “works.” If error, describe the error to AI and repeat. Never actually read or understand the code.</a:t>
+            </a:r>
+          </a:p>
+          <a:p>
+            <a:r>
+              <a:rPr lang="en-US" dirty="0"/>
+              <a:t>Why it leads to collapse:</a:t>
             </a:r>
           </a:p>
           <a:p>
             <a:pPr lvl="1"/>
             <a:r>
               <a:rPr lang="en-US" dirty="0"/>
-              <a:t>When you eventually use AI, you can evaluate and guide it effectively.</a:t>
+              <a:t>No troubleshooting capability — you don’t understand what the code does</a:t>
             </a:r>
           </a:p>
           <a:p>
             <a:pPr lvl="1"/>
             <a:r>
               <a:rPr lang="en-US" dirty="0"/>
-              <a:t>Solid foundation that supports long-term productivity growth.</a:t>
-            </a:r>
-          </a:p>
-          <a:p>
-            <a:r>
-              <a:rPr lang="en-US" b="1" dirty="0"/>
-              <a:t>Path B — AI First:</a:t>
+              <a:t>Can’t provide effective feedback — you can only describe symptoms, not problems</a:t>
             </a:r>
           </a:p>
           <a:p>
             <a:pPr lvl="1"/>
             <a:r>
               <a:rPr lang="en-US" dirty="0"/>
-              <a:t>Fast initial progress. But you never learn WHY the code works.</a:t>
-            </a:r>
-          </a:p>
-          <a:p>
-            <a:pPr lvl="1"/>
-            <a:r>
-              <a:rPr lang="en-US" dirty="0"/>
-              <a:t>When complex bugs hit, you’re stuck — you can’t even describe the problem to AI effectively.</a:t>
-            </a:r>
-          </a:p>
-          <a:p>
-            <a:pPr lvl="1"/>
-            <a:r>
-              <a:rPr lang="en-US" dirty="0"/>
-              <a:t>Productivity collapses and never recovers to Path A levels.</a:t>
-            </a:r>
+              <a:t>Brittle development — one change breaks everything and you don’t know why</a:t>
+            </a:r>
+          </a:p>
+          <a:p>
+            <a:r>
+              <a:rPr lang="en-US" dirty="0"/>
+              <a:t>To effectively use AI, you must be able to evaluate the code itself — not just “does it run?”</a:t>
+            </a:r>
+          </a:p>
+          <a:p>
+            <a:endParaRPr lang="en-US" dirty="0"/>
           </a:p>
         </p:txBody>
       </p:sp>
@@ -16708,13 +16725,7 @@
       </p:grpSpPr>
       <p:sp>
         <p:nvSpPr>
-          <p:cNvPr id="2" name="Title 1">
-            <a:extLst>
-              <a:ext uri="{FF2B5EF4-FFF2-40B4-BE49-F238E27FC236}">
-                <a16:creationId xmlns:a16="http://schemas.microsoft.com/office/drawing/2014/main" id="{D594D5D3-62C7-FC3A-5BF2-3B8E08DDA091}"/>
-              </a:ext>
-            </a:extLst>
-          </p:cNvPr>
+          <p:cNvPr id="2" name="Title 1"/>
           <p:cNvSpPr>
             <a:spLocks noGrp="1"/>
           </p:cNvSpPr>
@@ -16724,25 +16735,21 @@
         </p:nvSpPr>
         <p:spPr/>
         <p:txBody>
-          <a:bodyPr/>
-          <a:lstStyle/>
-          <a:p>
-            <a:r>
-              <a:rPr lang="en-US" dirty="0"/>
-              <a:t>A "learning-tax" strategy can help mitigate deskilling.</a:t>
-            </a:r>
-          </a:p>
-        </p:txBody>
-      </p:sp>
-      <p:sp>
-        <p:nvSpPr>
-          <p:cNvPr id="3" name="Content Placeholder 2">
-            <a:extLst>
-              <a:ext uri="{FF2B5EF4-FFF2-40B4-BE49-F238E27FC236}">
-                <a16:creationId xmlns:a16="http://schemas.microsoft.com/office/drawing/2014/main" id="{391A5C37-C6EC-6BD1-ED22-C0F09F2537F6}"/>
-              </a:ext>
-            </a:extLst>
-          </p:cNvPr>
+          <a:bodyPr>
+            <a:normAutofit/>
+          </a:bodyPr>
+          <a:lstStyle/>
+          <a:p>
+            <a:r>
+              <a:rPr lang="en-US" sz="3200" dirty="0"/>
+              <a:t>Trap #2: AI Creates “Learning Debt” When Used Too Early</a:t>
+            </a:r>
+          </a:p>
+        </p:txBody>
+      </p:sp>
+      <p:sp>
+        <p:nvSpPr>
+          <p:cNvPr id="3" name="Content Placeholder 2"/>
           <p:cNvSpPr>
             <a:spLocks noGrp="1"/>
           </p:cNvSpPr>
@@ -16752,37 +16759,69 @@
         </p:nvSpPr>
         <p:spPr/>
         <p:txBody>
-          <a:bodyPr/>
-          <a:lstStyle/>
-          <a:p>
-            <a:r>
-              <a:rPr lang="en-US" dirty="0"/>
-              <a:t>Adopt a “learning tax” strategy: deliberately choose to implement certain components manually, even when AI could generate them instantly.</a:t>
-            </a:r>
-          </a:p>
-          <a:p>
-            <a:r>
-              <a:rPr lang="en-US" dirty="0"/>
-              <a:t>Otherwise you won't recognize when the AI is screwing up!</a:t>
-            </a:r>
-          </a:p>
-          <a:p>
-            <a:r>
-              <a:rPr lang="en-US" dirty="0"/>
-              <a:t>The goal isn’t to code without AI or to use it for everything, but to maintain the expertise that makes you irreplaceable—the judgment, creativity, and deep understanding that transforms good code into great software. (--Jon Bell)</a:t>
-            </a:r>
-          </a:p>
-        </p:txBody>
-      </p:sp>
-      <p:sp>
-        <p:nvSpPr>
-          <p:cNvPr id="4" name="Slide Number Placeholder 3">
-            <a:extLst>
-              <a:ext uri="{FF2B5EF4-FFF2-40B4-BE49-F238E27FC236}">
-                <a16:creationId xmlns:a16="http://schemas.microsoft.com/office/drawing/2014/main" id="{B5A705CD-F17C-2935-2551-EF05FC294324}"/>
-              </a:ext>
-            </a:extLst>
-          </p:cNvPr>
+          <a:bodyPr>
+            <a:normAutofit fontScale="92500"/>
+          </a:bodyPr>
+          <a:lstStyle/>
+          <a:p>
+            <a:r>
+              <a:rPr lang="en-US" b="1" dirty="0"/>
+              <a:t>Path A — Learning First (recommended):</a:t>
+            </a:r>
+          </a:p>
+          <a:p>
+            <a:pPr lvl="1"/>
+            <a:r>
+              <a:rPr lang="en-US" dirty="0"/>
+              <a:t>Manual coding, mistakes, understanding errors, building mental models. Slower at first.</a:t>
+            </a:r>
+          </a:p>
+          <a:p>
+            <a:pPr lvl="1"/>
+            <a:r>
+              <a:rPr lang="en-US" dirty="0"/>
+              <a:t>When you eventually use AI, you can evaluate and guide it effectively.</a:t>
+            </a:r>
+          </a:p>
+          <a:p>
+            <a:pPr lvl="1"/>
+            <a:r>
+              <a:rPr lang="en-US" dirty="0"/>
+              <a:t>Solid foundation that supports long-term productivity growth.</a:t>
+            </a:r>
+          </a:p>
+          <a:p>
+            <a:r>
+              <a:rPr lang="en-US" b="1" dirty="0"/>
+              <a:t>Path B — AI First:</a:t>
+            </a:r>
+          </a:p>
+          <a:p>
+            <a:pPr lvl="1"/>
+            <a:r>
+              <a:rPr lang="en-US" dirty="0"/>
+              <a:t>Fast initial progress. But you never learn WHY the code works.</a:t>
+            </a:r>
+          </a:p>
+          <a:p>
+            <a:pPr lvl="1"/>
+            <a:r>
+              <a:rPr lang="en-US" dirty="0"/>
+              <a:t>When complex bugs hit, you’re stuck — you can’t even describe the problem to AI effectively.</a:t>
+            </a:r>
+          </a:p>
+          <a:p>
+            <a:pPr lvl="1"/>
+            <a:r>
+              <a:rPr lang="en-US" dirty="0"/>
+              <a:t>Productivity collapses and never recovers to Path A levels.</a:t>
+            </a:r>
+          </a:p>
+        </p:txBody>
+      </p:sp>
+      <p:sp>
+        <p:nvSpPr>
+          <p:cNvPr id="4" name="Slide Number Placeholder 3"/>
           <p:cNvSpPr>
             <a:spLocks noGrp="1"/>
           </p:cNvSpPr>
@@ -16798,6 +16837,128 @@
             <a:fld id="{20F37917-FD3A-4669-9018-DA04BCDD3D75}" type="slidenum">
               <a:rPr lang="en-US" smtClean="0"/>
               <a:t>42</a:t>
+            </a:fld>
+            <a:endParaRPr lang="en-US"/>
+          </a:p>
+        </p:txBody>
+      </p:sp>
+    </p:spTree>
+  </p:cSld>
+  <p:clrMapOvr>
+    <a:masterClrMapping/>
+  </p:clrMapOvr>
+</p:sld>
+</file>
+
+<file path=ppt/slides/slide43.xml><?xml version="1.0" encoding="utf-8"?>
+<p:sld xmlns:a="http://schemas.openxmlformats.org/drawingml/2006/main" xmlns:r="http://schemas.openxmlformats.org/officeDocument/2006/relationships" xmlns:p="http://schemas.openxmlformats.org/presentationml/2006/main">
+  <p:cSld>
+    <p:spTree>
+      <p:nvGrpSpPr>
+        <p:cNvPr id="1" name=""/>
+        <p:cNvGrpSpPr/>
+        <p:nvPr/>
+      </p:nvGrpSpPr>
+      <p:grpSpPr>
+        <a:xfrm>
+          <a:off x="0" y="0"/>
+          <a:ext cx="0" cy="0"/>
+          <a:chOff x="0" y="0"/>
+          <a:chExt cx="0" cy="0"/>
+        </a:xfrm>
+      </p:grpSpPr>
+      <p:sp>
+        <p:nvSpPr>
+          <p:cNvPr id="2" name="Title 1">
+            <a:extLst>
+              <a:ext uri="{FF2B5EF4-FFF2-40B4-BE49-F238E27FC236}">
+                <a16:creationId xmlns:a16="http://schemas.microsoft.com/office/drawing/2014/main" id="{D594D5D3-62C7-FC3A-5BF2-3B8E08DDA091}"/>
+              </a:ext>
+            </a:extLst>
+          </p:cNvPr>
+          <p:cNvSpPr>
+            <a:spLocks noGrp="1"/>
+          </p:cNvSpPr>
+          <p:nvPr>
+            <p:ph type="title"/>
+          </p:nvPr>
+        </p:nvSpPr>
+        <p:spPr/>
+        <p:txBody>
+          <a:bodyPr/>
+          <a:lstStyle/>
+          <a:p>
+            <a:r>
+              <a:rPr lang="en-US" dirty="0"/>
+              <a:t>A "learning-tax" strategy can help mitigate deskilling.</a:t>
+            </a:r>
+          </a:p>
+        </p:txBody>
+      </p:sp>
+      <p:sp>
+        <p:nvSpPr>
+          <p:cNvPr id="3" name="Content Placeholder 2">
+            <a:extLst>
+              <a:ext uri="{FF2B5EF4-FFF2-40B4-BE49-F238E27FC236}">
+                <a16:creationId xmlns:a16="http://schemas.microsoft.com/office/drawing/2014/main" id="{391A5C37-C6EC-6BD1-ED22-C0F09F2537F6}"/>
+              </a:ext>
+            </a:extLst>
+          </p:cNvPr>
+          <p:cNvSpPr>
+            <a:spLocks noGrp="1"/>
+          </p:cNvSpPr>
+          <p:nvPr>
+            <p:ph idx="1"/>
+          </p:nvPr>
+        </p:nvSpPr>
+        <p:spPr/>
+        <p:txBody>
+          <a:bodyPr/>
+          <a:lstStyle/>
+          <a:p>
+            <a:r>
+              <a:rPr lang="en-US" dirty="0"/>
+              <a:t>Adopt a “learning tax” strategy: deliberately choose to implement certain components manually, even when AI could generate them instantly.</a:t>
+            </a:r>
+          </a:p>
+          <a:p>
+            <a:r>
+              <a:rPr lang="en-US" dirty="0"/>
+              <a:t>Otherwise you won't recognize when the AI is screwing up!</a:t>
+            </a:r>
+          </a:p>
+          <a:p>
+            <a:r>
+              <a:rPr lang="en-US" dirty="0"/>
+              <a:t>The goal isn’t to code without AI or to use it for everything, but to maintain the expertise that makes you irreplaceable—the judgment, creativity, and deep understanding that transforms good code into great software. (--Jon Bell)</a:t>
+            </a:r>
+          </a:p>
+        </p:txBody>
+      </p:sp>
+      <p:sp>
+        <p:nvSpPr>
+          <p:cNvPr id="4" name="Slide Number Placeholder 3">
+            <a:extLst>
+              <a:ext uri="{FF2B5EF4-FFF2-40B4-BE49-F238E27FC236}">
+                <a16:creationId xmlns:a16="http://schemas.microsoft.com/office/drawing/2014/main" id="{B5A705CD-F17C-2935-2551-EF05FC294324}"/>
+              </a:ext>
+            </a:extLst>
+          </p:cNvPr>
+          <p:cNvSpPr>
+            <a:spLocks noGrp="1"/>
+          </p:cNvSpPr>
+          <p:nvPr>
+            <p:ph type="sldNum" sz="quarter" idx="12"/>
+          </p:nvPr>
+        </p:nvSpPr>
+        <p:spPr/>
+        <p:txBody>
+          <a:bodyPr/>
+          <a:lstStyle/>
+          <a:p>
+            <a:fld id="{20F37917-FD3A-4669-9018-DA04BCDD3D75}" type="slidenum">
+              <a:rPr lang="en-US" smtClean="0"/>
+              <a:t>43</a:t>
             </a:fld>
             <a:endParaRPr lang="en-US"/>
           </a:p>
@@ -16816,7 +16977,7 @@
 </p:sld>
 </file>
 
-<file path=ppt/slides/slide43.xml><?xml version="1.0" encoding="utf-8"?>
+<file path=ppt/slides/slide44.xml><?xml version="1.0" encoding="utf-8"?>
 <p:sld xmlns:a="http://schemas.openxmlformats.org/drawingml/2006/main" xmlns:r="http://schemas.openxmlformats.org/officeDocument/2006/relationships" xmlns:p="http://schemas.openxmlformats.org/presentationml/2006/main">
   <p:cSld>
     <p:spTree>
@@ -17052,7 +17213,7 @@
                 <a:tabLst/>
                 <a:defRPr/>
               </a:pPr>
-              <a:t>43</a:t>
+              <a:t>44</a:t>
             </a:fld>
             <a:endParaRPr kumimoji="0" lang="en-US" sz="1200" b="0" i="0" u="none" strike="noStrike" kern="1200" cap="none" spc="0" normalizeH="0" baseline="0" noProof="0">
               <a:ln>

</xml_diff>